<commit_message>
feat: enhance 5-slide deck with executive card containers, candidate branding, and live Render URL
</commit_message>
<xml_diff>
--- a/revenue-inbox/slides/presentation.pptx
+++ b/revenue-inbox/slides/presentation.pptx
@@ -3108,8 +3108,8 @@
         </p:nvSpPr>
         <p:spPr>
           <a:xfrm>
-            <a:off x="731520" y="457200"/>
-            <a:ext cx="10698480" cy="365760"/>
+            <a:off x="731520" y="365760"/>
+            <a:ext cx="10698480" cy="320040"/>
           </a:xfrm>
           <a:prstGeom prst="rect">
             <a:avLst/>
@@ -3117,20 +3117,20 @@
           <a:noFill/>
         </p:spPr>
         <p:txBody>
-          <a:bodyPr wrap="none">
+          <a:bodyPr wrap="square">
             <a:spAutoFit/>
           </a:bodyPr>
           <a:lstStyle/>
           <a:p>
             <a:pPr>
-              <a:defRPr sz="1100" b="1">
+              <a:defRPr sz="1000" b="1">
                 <a:solidFill>
                   <a:srgbClr val="06B6D4"/>
                 </a:solidFill>
               </a:defRPr>
             </a:pPr>
             <a:r>
-              <a:t>SLIDE 1 • PROBLEM DEFINITION &amp; GROUND-TRUTH EVIDENCE</a:t>
+              <a:t>VOLOPAY EVALUATION  •  SLIDE 1 • PROBLEM CONTEXT &amp; GROUND-TRUTH EVIDENCE</a:t>
             </a:r>
           </a:p>
         </p:txBody>
@@ -3143,8 +3143,8 @@
         </p:nvSpPr>
         <p:spPr>
           <a:xfrm>
-            <a:off x="731520" y="777240"/>
-            <a:ext cx="10698480" cy="640080"/>
+            <a:off x="731520" y="685800"/>
+            <a:ext cx="10698480" cy="594360"/>
           </a:xfrm>
           <a:prstGeom prst="rect">
             <a:avLst/>
@@ -3152,20 +3152,20 @@
           <a:noFill/>
         </p:spPr>
         <p:txBody>
-          <a:bodyPr wrap="none">
+          <a:bodyPr wrap="square">
             <a:spAutoFit/>
           </a:bodyPr>
           <a:lstStyle/>
           <a:p>
             <a:pPr>
-              <a:defRPr sz="2400" b="1">
+              <a:defRPr sz="2200" b="1">
                 <a:solidFill>
                   <a:srgbClr val="F8FAFC"/>
                 </a:solidFill>
               </a:defRPr>
             </a:pPr>
             <a:r>
-              <a:t>1. The Manager Problem Solved &amp; 3 Key Findings</a:t>
+              <a:t>1. The Manager Problem Solved &amp; 3 Key Source Findings</a:t>
             </a:r>
           </a:p>
         </p:txBody>
@@ -3178,7 +3178,7 @@
         </p:nvSpPr>
         <p:spPr>
           <a:xfrm>
-            <a:off x="731520" y="6217920"/>
+            <a:off x="731520" y="6309360"/>
             <a:ext cx="10698480" cy="365760"/>
           </a:xfrm>
           <a:prstGeom prst="rect">
@@ -3193,28 +3193,73 @@
           <a:lstStyle/>
           <a:p>
             <a:pPr>
-              <a:defRPr sz="1000">
+              <a:defRPr sz="950">
                 <a:solidFill>
                   <a:srgbClr val="94A3B8"/>
                 </a:solidFill>
               </a:defRPr>
             </a:pPr>
             <a:r>
-              <a:t>SpendNest Revenue Intelligence Inbox — Volopay Assessment | Slide 1 of 5</a:t>
-            </a:r>
-          </a:p>
-        </p:txBody>
-      </p:sp>
-      <p:sp>
-        <p:nvSpPr>
-          <p:cNvPr id="5" name="TextBox 4"/>
+              <a:t>SpendNest Revenue Intelligence Inbox  •  Candidate: Dinesh Madhavan M  •  Live: https://volopay-assignment-inqe.onrender.com  •  Slide 1 of 5</a:t>
+            </a:r>
+          </a:p>
+        </p:txBody>
+      </p:sp>
+      <p:sp>
+        <p:nvSpPr>
+          <p:cNvPr id="5" name="Rounded Rectangle 4"/>
+          <p:cNvSpPr/>
+          <p:nvPr/>
+        </p:nvSpPr>
+        <p:spPr>
+          <a:xfrm>
+            <a:off x="731520" y="1371600"/>
+            <a:ext cx="10728655" cy="914400"/>
+          </a:xfrm>
+          <a:prstGeom prst="roundRect">
+            <a:avLst/>
+          </a:prstGeom>
+          <a:solidFill>
+            <a:srgbClr val="131A2B"/>
+          </a:solidFill>
+          <a:ln w="15240">
+            <a:solidFill>
+              <a:srgbClr val="25304D"/>
+            </a:solidFill>
+          </a:ln>
+        </p:spPr>
+        <p:style>
+          <a:lnRef idx="1">
+            <a:schemeClr val="accent1"/>
+          </a:lnRef>
+          <a:fillRef idx="3">
+            <a:schemeClr val="accent1"/>
+          </a:fillRef>
+          <a:effectRef idx="2">
+            <a:schemeClr val="accent1"/>
+          </a:effectRef>
+          <a:fontRef idx="minor">
+            <a:schemeClr val="lt1"/>
+          </a:fontRef>
+        </p:style>
+        <p:txBody>
+          <a:bodyPr rtlCol="0" anchor="ctr"/>
+          <a:lstStyle/>
+          <a:p>
+            <a:pPr algn="ctr"/>
+          </a:p>
+        </p:txBody>
+      </p:sp>
+      <p:sp>
+        <p:nvSpPr>
+          <p:cNvPr id="6" name="TextBox 5"/>
           <p:cNvSpPr txBox="1"/>
           <p:nvPr/>
         </p:nvSpPr>
         <p:spPr>
           <a:xfrm>
-            <a:off x="731520" y="1463040"/>
-            <a:ext cx="10698480" cy="4572000"/>
+            <a:off x="914400" y="1417320"/>
+            <a:ext cx="10362895" cy="822960"/>
           </a:xfrm>
           <a:prstGeom prst="rect">
             <a:avLst/>
@@ -3228,44 +3273,106 @@
           <a:lstStyle/>
           <a:p>
             <a:pPr>
-              <a:spcAft>
-                <a:spcPts val="1400"/>
-              </a:spcAft>
-              <a:defRPr sz="1300">
-                <a:solidFill>
-                  <a:srgbClr val="94A3B8"/>
-                </a:solidFill>
-              </a:defRPr>
-            </a:pPr>
-            <a:r>
-              <a:t>The Problem: Sales managers receive messy telephony &amp; calendar logs where labels contradict reality, background dials inflate activity counts, and vendor meetings are mistakenly counted as pipeline.</a:t>
-            </a:r>
-          </a:p>
-          <a:p>
-            <a:pPr>
-              <a:spcAft>
-                <a:spcPts val="1000"/>
-              </a:spcAft>
-              <a:defRPr sz="1400" b="1">
+              <a:defRPr b="1" sz="1200">
                 <a:solidFill>
                   <a:srgbClr val="6366F1"/>
                 </a:solidFill>
               </a:defRPr>
             </a:pPr>
             <a:r>
-              <a:t>Three Critical Findings Linked to Exact Source Evidence:</a:t>
-            </a:r>
-          </a:p>
-          <a:p>
-            <a:pPr>
-              <a:defRPr sz="1200" b="1">
+              <a:t>The Manager Problem:</a:t>
+            </a:r>
+          </a:p>
+          <a:p>
+            <a:pPr>
+              <a:defRPr sz="1100">
                 <a:solidFill>
                   <a:srgbClr val="F8FAFC"/>
                 </a:solidFill>
               </a:defRPr>
             </a:pPr>
             <a:r>
-              <a:t>• Finding 1: Vendor Evaluation Mistagged as Sales Pipeline (M02 - LedgerBridge)</a:t>
+              <a:t>A sales manager receives fragmented telephony and calendar logs from multiple sources where labels contradict reality, background dials inflate activity counts, and vendor procurement discussions are misclassified as inbound sales leads.</a:t>
+            </a:r>
+          </a:p>
+        </p:txBody>
+      </p:sp>
+      <p:sp>
+        <p:nvSpPr>
+          <p:cNvPr id="7" name="Rounded Rectangle 6"/>
+          <p:cNvSpPr/>
+          <p:nvPr/>
+        </p:nvSpPr>
+        <p:spPr>
+          <a:xfrm>
+            <a:off x="731520" y="2423160"/>
+            <a:ext cx="3429000" cy="3703320"/>
+          </a:xfrm>
+          <a:prstGeom prst="roundRect">
+            <a:avLst/>
+          </a:prstGeom>
+          <a:solidFill>
+            <a:srgbClr val="131A2B"/>
+          </a:solidFill>
+          <a:ln w="15240">
+            <a:solidFill>
+              <a:srgbClr val="6366F1"/>
+            </a:solidFill>
+          </a:ln>
+        </p:spPr>
+        <p:style>
+          <a:lnRef idx="1">
+            <a:schemeClr val="accent1"/>
+          </a:lnRef>
+          <a:fillRef idx="3">
+            <a:schemeClr val="accent1"/>
+          </a:fillRef>
+          <a:effectRef idx="2">
+            <a:schemeClr val="accent1"/>
+          </a:effectRef>
+          <a:fontRef idx="minor">
+            <a:schemeClr val="lt1"/>
+          </a:fontRef>
+        </p:style>
+        <p:txBody>
+          <a:bodyPr rtlCol="0" anchor="ctr"/>
+          <a:lstStyle/>
+          <a:p>
+            <a:pPr algn="ctr"/>
+          </a:p>
+        </p:txBody>
+      </p:sp>
+      <p:sp>
+        <p:nvSpPr>
+          <p:cNvPr id="8" name="TextBox 7"/>
+          <p:cNvSpPr txBox="1"/>
+          <p:nvPr/>
+        </p:nvSpPr>
+        <p:spPr>
+          <a:xfrm>
+            <a:off x="868680" y="2560320"/>
+            <a:ext cx="3154680" cy="3429000"/>
+          </a:xfrm>
+          <a:prstGeom prst="rect">
+            <a:avLst/>
+          </a:prstGeom>
+          <a:noFill/>
+        </p:spPr>
+        <p:txBody>
+          <a:bodyPr wrap="square">
+            <a:spAutoFit/>
+          </a:bodyPr>
+          <a:lstStyle/>
+          <a:p>
+            <a:pPr>
+              <a:defRPr sz="1000" b="1">
+                <a:solidFill>
+                  <a:srgbClr val="6366F1"/>
+                </a:solidFill>
+              </a:defRPr>
+            </a:pPr>
+            <a:r>
+              <a:t>MEETING M02 — LEDGERBRIDGE</a:t>
             </a:r>
           </a:p>
           <a:p>
@@ -3273,30 +3380,26 @@
               <a:spcAft>
                 <a:spcPts val="800"/>
               </a:spcAft>
-              <a:defRPr sz="1100">
+              <a:defRPr sz="1300" b="1">
+                <a:solidFill>
+                  <a:srgbClr val="F8FAFC"/>
+                </a:solidFill>
+              </a:defRPr>
+            </a:pPr>
+            <a:r>
+              <a:t>Finding 1: Vendor Misclassified as Sales Pipeline</a:t>
+            </a:r>
+          </a:p>
+          <a:p>
+            <a:pPr>
+              <a:defRPr sz="950" b="1">
                 <a:solidFill>
                   <a:srgbClr val="94A3B8"/>
                 </a:solidFill>
               </a:defRPr>
             </a:pPr>
             <a:r>
-              <a:t>   Evidence (Turn 1): 'I work on strategy and partnerships at SpendNest... We want to understand whether LedgerBridge can give us compliant invoicing coverage in Europe...'</a:t>
-            </a:r>
-            <a:br/>
-            <a:r>
-              <a:t>Impact: SpendNest is the buyer! Upstream CRM tagged this as sales pipeline. Our system routes it to Vendor Evaluation / Internal, protecting quota and forecasting accuracy.</a:t>
-            </a:r>
-          </a:p>
-          <a:p>
-            <a:pPr>
-              <a:defRPr sz="1200" b="1">
-                <a:solidFill>
-                  <a:srgbClr val="F8FAFC"/>
-                </a:solidFill>
-              </a:defRPr>
-            </a:pPr>
-            <a:r>
-              <a:t>• Finding 2: Telephony User Identity Mismatch (Call C06)</a:t>
+              <a:t>SOURCE PASSAGE EVIDENCE:</a:t>
             </a:r>
           </a:p>
           <a:p>
@@ -3304,30 +3407,118 @@
               <a:spcAft>
                 <a:spcPts val="800"/>
               </a:spcAft>
-              <a:defRPr sz="1100">
-                <a:solidFill>
-                  <a:srgbClr val="94A3B8"/>
-                </a:solidFill>
-              </a:defRPr>
-            </a:pPr>
-            <a:r>
-              <a:t>   Evidence (Verbatim quote): 'Good evening, Mr Nikhil... Ravi here. I'll say at the start that this is a cold call.'</a:t>
-            </a:r>
-            <a:br/>
-            <a:r>
-              <a:t>Impact: Telephony metadata lists rep as Meera, but spoken audio is Ravi. Flagged as Rep Coaching / Data Discrepancy to prevent commission and coaching misallocation.</a:t>
-            </a:r>
-          </a:p>
-          <a:p>
-            <a:pPr>
-              <a:defRPr sz="1200" b="1">
+              <a:defRPr sz="1000" i="1">
                 <a:solidFill>
                   <a:srgbClr val="F8FAFC"/>
                 </a:solidFill>
               </a:defRPr>
             </a:pPr>
             <a:r>
-              <a:t>• Finding 3: Product Capability Disconnect (Meeting M01 - Harborpath Advisory)</a:t>
+              <a:t>"Turn 1: 'I work on strategy and partnerships at SpendNest... We want to understand whether LedgerBridge can give us compliant invoicing coverage in Europe...'"</a:t>
+            </a:r>
+          </a:p>
+          <a:p>
+            <a:pPr>
+              <a:defRPr sz="950" b="1">
+                <a:solidFill>
+                  <a:srgbClr val="6366F1"/>
+                </a:solidFill>
+              </a:defRPr>
+            </a:pPr>
+            <a:r>
+              <a:t>PRODUCT DECISION / IMPACT:</a:t>
+            </a:r>
+          </a:p>
+          <a:p>
+            <a:pPr>
+              <a:defRPr sz="1000">
+                <a:solidFill>
+                  <a:srgbClr val="F8FAFC"/>
+                </a:solidFill>
+              </a:defRPr>
+            </a:pPr>
+            <a:r>
+              <a:t>SpendNest is the buyer! Upstream CRM tagged this as sales pipeline. Our system routes it to Vendor Evaluation / Internal, protecting quota and forecasting integrity.</a:t>
+            </a:r>
+          </a:p>
+        </p:txBody>
+      </p:sp>
+      <p:sp>
+        <p:nvSpPr>
+          <p:cNvPr id="9" name="Rounded Rectangle 8"/>
+          <p:cNvSpPr/>
+          <p:nvPr/>
+        </p:nvSpPr>
+        <p:spPr>
+          <a:xfrm>
+            <a:off x="4379976" y="2423160"/>
+            <a:ext cx="3429000" cy="3703320"/>
+          </a:xfrm>
+          <a:prstGeom prst="roundRect">
+            <a:avLst/>
+          </a:prstGeom>
+          <a:solidFill>
+            <a:srgbClr val="131A2B"/>
+          </a:solidFill>
+          <a:ln w="15240">
+            <a:solidFill>
+              <a:srgbClr val="F59E0B"/>
+            </a:solidFill>
+          </a:ln>
+        </p:spPr>
+        <p:style>
+          <a:lnRef idx="1">
+            <a:schemeClr val="accent1"/>
+          </a:lnRef>
+          <a:fillRef idx="3">
+            <a:schemeClr val="accent1"/>
+          </a:fillRef>
+          <a:effectRef idx="2">
+            <a:schemeClr val="accent1"/>
+          </a:effectRef>
+          <a:fontRef idx="minor">
+            <a:schemeClr val="lt1"/>
+          </a:fontRef>
+        </p:style>
+        <p:txBody>
+          <a:bodyPr rtlCol="0" anchor="ctr"/>
+          <a:lstStyle/>
+          <a:p>
+            <a:pPr algn="ctr"/>
+          </a:p>
+        </p:txBody>
+      </p:sp>
+      <p:sp>
+        <p:nvSpPr>
+          <p:cNvPr id="10" name="TextBox 9"/>
+          <p:cNvSpPr txBox="1"/>
+          <p:nvPr/>
+        </p:nvSpPr>
+        <p:spPr>
+          <a:xfrm>
+            <a:off x="4517136" y="2560320"/>
+            <a:ext cx="3154680" cy="3429000"/>
+          </a:xfrm>
+          <a:prstGeom prst="rect">
+            <a:avLst/>
+          </a:prstGeom>
+          <a:noFill/>
+        </p:spPr>
+        <p:txBody>
+          <a:bodyPr wrap="square">
+            <a:spAutoFit/>
+          </a:bodyPr>
+          <a:lstStyle/>
+          <a:p>
+            <a:pPr>
+              <a:defRPr sz="1000" b="1">
+                <a:solidFill>
+                  <a:srgbClr val="F59E0B"/>
+                </a:solidFill>
+              </a:defRPr>
+            </a:pPr>
+            <a:r>
+              <a:t>CALL C06 — MEERA VS. RAVI</a:t>
             </a:r>
           </a:p>
           <a:p>
@@ -3335,18 +3526,211 @@
               <a:spcAft>
                 <a:spcPts val="800"/>
               </a:spcAft>
-              <a:defRPr sz="1100">
+              <a:defRPr sz="1300" b="1">
+                <a:solidFill>
+                  <a:srgbClr val="F8FAFC"/>
+                </a:solidFill>
+              </a:defRPr>
+            </a:pPr>
+            <a:r>
+              <a:t>Finding 2: Telephony User Identity Mismatch</a:t>
+            </a:r>
+          </a:p>
+          <a:p>
+            <a:pPr>
+              <a:defRPr sz="950" b="1">
                 <a:solidFill>
                   <a:srgbClr val="94A3B8"/>
                 </a:solidFill>
               </a:defRPr>
             </a:pPr>
             <a:r>
-              <a:t>   Evidence (Turn 1 &amp; 2): Partner seeks remote bank account opening. SpendNest clarifies: 'we provide virtual business accounts for operational spend, not licensed retail bank accounts...'</a:t>
-            </a:r>
-            <a:br/>
-            <a:r>
-              <a:t>Impact: Channel partner risk. Must deliver compliance positioning before launching partner referrals.</a:t>
+              <a:t>SOURCE PASSAGE EVIDENCE:</a:t>
+            </a:r>
+          </a:p>
+          <a:p>
+            <a:pPr>
+              <a:spcAft>
+                <a:spcPts val="800"/>
+              </a:spcAft>
+              <a:defRPr sz="1000" i="1">
+                <a:solidFill>
+                  <a:srgbClr val="F8FAFC"/>
+                </a:solidFill>
+              </a:defRPr>
+            </a:pPr>
+            <a:r>
+              <a:t>"Verbatim Spoken Audio: 'Good evening, Mr Nikhil... Ravi here. I'll say at the start that this is a cold call.'"</a:t>
+            </a:r>
+          </a:p>
+          <a:p>
+            <a:pPr>
+              <a:defRPr sz="950" b="1">
+                <a:solidFill>
+                  <a:srgbClr val="F59E0B"/>
+                </a:solidFill>
+              </a:defRPr>
+            </a:pPr>
+            <a:r>
+              <a:t>PRODUCT DECISION / IMPACT:</a:t>
+            </a:r>
+          </a:p>
+          <a:p>
+            <a:pPr>
+              <a:defRPr sz="1000">
+                <a:solidFill>
+                  <a:srgbClr val="F8FAFC"/>
+                </a:solidFill>
+              </a:defRPr>
+            </a:pPr>
+            <a:r>
+              <a:t>Telephony metadata attributes the dial to Meera, but spoken audio is Ravi. Flagged as Rep Coaching / Discrepancy Alert to prevent coaching and commission misallocation.</a:t>
+            </a:r>
+          </a:p>
+        </p:txBody>
+      </p:sp>
+      <p:sp>
+        <p:nvSpPr>
+          <p:cNvPr id="11" name="Rounded Rectangle 10"/>
+          <p:cNvSpPr/>
+          <p:nvPr/>
+        </p:nvSpPr>
+        <p:spPr>
+          <a:xfrm>
+            <a:off x="8028432" y="2423160"/>
+            <a:ext cx="3429000" cy="3703320"/>
+          </a:xfrm>
+          <a:prstGeom prst="roundRect">
+            <a:avLst/>
+          </a:prstGeom>
+          <a:solidFill>
+            <a:srgbClr val="131A2B"/>
+          </a:solidFill>
+          <a:ln w="15240">
+            <a:solidFill>
+              <a:srgbClr val="06B6D4"/>
+            </a:solidFill>
+          </a:ln>
+        </p:spPr>
+        <p:style>
+          <a:lnRef idx="1">
+            <a:schemeClr val="accent1"/>
+          </a:lnRef>
+          <a:fillRef idx="3">
+            <a:schemeClr val="accent1"/>
+          </a:fillRef>
+          <a:effectRef idx="2">
+            <a:schemeClr val="accent1"/>
+          </a:effectRef>
+          <a:fontRef idx="minor">
+            <a:schemeClr val="lt1"/>
+          </a:fontRef>
+        </p:style>
+        <p:txBody>
+          <a:bodyPr rtlCol="0" anchor="ctr"/>
+          <a:lstStyle/>
+          <a:p>
+            <a:pPr algn="ctr"/>
+          </a:p>
+        </p:txBody>
+      </p:sp>
+      <p:sp>
+        <p:nvSpPr>
+          <p:cNvPr id="12" name="TextBox 11"/>
+          <p:cNvSpPr txBox="1"/>
+          <p:nvPr/>
+        </p:nvSpPr>
+        <p:spPr>
+          <a:xfrm>
+            <a:off x="8165592" y="2560320"/>
+            <a:ext cx="3154680" cy="3429000"/>
+          </a:xfrm>
+          <a:prstGeom prst="rect">
+            <a:avLst/>
+          </a:prstGeom>
+          <a:noFill/>
+        </p:spPr>
+        <p:txBody>
+          <a:bodyPr wrap="square">
+            <a:spAutoFit/>
+          </a:bodyPr>
+          <a:lstStyle/>
+          <a:p>
+            <a:pPr>
+              <a:defRPr sz="1000" b="1">
+                <a:solidFill>
+                  <a:srgbClr val="06B6D4"/>
+                </a:solidFill>
+              </a:defRPr>
+            </a:pPr>
+            <a:r>
+              <a:t>MEETING M01 — HARBORPATH ADVISORY</a:t>
+            </a:r>
+          </a:p>
+          <a:p>
+            <a:pPr>
+              <a:spcAft>
+                <a:spcPts val="800"/>
+              </a:spcAft>
+              <a:defRPr sz="1300" b="1">
+                <a:solidFill>
+                  <a:srgbClr val="F8FAFC"/>
+                </a:solidFill>
+              </a:defRPr>
+            </a:pPr>
+            <a:r>
+              <a:t>Finding 3: Channel Capability Disconnect</a:t>
+            </a:r>
+          </a:p>
+          <a:p>
+            <a:pPr>
+              <a:defRPr sz="950" b="1">
+                <a:solidFill>
+                  <a:srgbClr val="94A3B8"/>
+                </a:solidFill>
+              </a:defRPr>
+            </a:pPr>
+            <a:r>
+              <a:t>SOURCE PASSAGE EVIDENCE:</a:t>
+            </a:r>
+          </a:p>
+          <a:p>
+            <a:pPr>
+              <a:spcAft>
+                <a:spcPts val="800"/>
+              </a:spcAft>
+              <a:defRPr sz="1000" i="1">
+                <a:solidFill>
+                  <a:srgbClr val="F8FAFC"/>
+                </a:solidFill>
+              </a:defRPr>
+            </a:pPr>
+            <a:r>
+              <a:t>"Turn 1 &amp; 2: Partner seeks remote bank account opening. SpendNest clarifies: 'we provide virtual business accounts for spend, not licensed retail bank accounts...'"</a:t>
+            </a:r>
+          </a:p>
+          <a:p>
+            <a:pPr>
+              <a:defRPr sz="950" b="1">
+                <a:solidFill>
+                  <a:srgbClr val="06B6D4"/>
+                </a:solidFill>
+              </a:defRPr>
+            </a:pPr>
+            <a:r>
+              <a:t>PRODUCT DECISION / IMPACT:</a:t>
+            </a:r>
+          </a:p>
+          <a:p>
+            <a:pPr>
+              <a:defRPr sz="1000">
+                <a:solidFill>
+                  <a:srgbClr val="F8FAFC"/>
+                </a:solidFill>
+              </a:defRPr>
+            </a:pPr>
+            <a:r>
+              <a:t>Channel partner expectation risk. Routed to Partnerships with requirement to supply compliance positioning collateral before onboarding overseas clients.</a:t>
             </a:r>
           </a:p>
         </p:txBody>
@@ -3385,8 +3769,8 @@
         </p:nvSpPr>
         <p:spPr>
           <a:xfrm>
-            <a:off x="731520" y="457200"/>
-            <a:ext cx="10698480" cy="365760"/>
+            <a:off x="731520" y="365760"/>
+            <a:ext cx="10698480" cy="320040"/>
           </a:xfrm>
           <a:prstGeom prst="rect">
             <a:avLst/>
@@ -3394,20 +3778,20 @@
           <a:noFill/>
         </p:spPr>
         <p:txBody>
-          <a:bodyPr wrap="none">
+          <a:bodyPr wrap="square">
             <a:spAutoFit/>
           </a:bodyPr>
           <a:lstStyle/>
           <a:p>
             <a:pPr>
-              <a:defRPr sz="1100" b="1">
+              <a:defRPr sz="1000" b="1">
                 <a:solidFill>
                   <a:srgbClr val="06B6D4"/>
                 </a:solidFill>
               </a:defRPr>
             </a:pPr>
             <a:r>
-              <a:t>SLIDE 2 • UX DESIGN PHILOSOPHY &amp; SYSTEM BOUNDARIES</a:t>
+              <a:t>VOLOPAY EVALUATION  •  SLIDE 2 • UX DESIGN PHILOSOPHY &amp; BOUNDARIES</a:t>
             </a:r>
           </a:p>
         </p:txBody>
@@ -3420,8 +3804,8 @@
         </p:nvSpPr>
         <p:spPr>
           <a:xfrm>
-            <a:off x="731520" y="777240"/>
-            <a:ext cx="10698480" cy="640080"/>
+            <a:off x="731520" y="685800"/>
+            <a:ext cx="10698480" cy="594360"/>
           </a:xfrm>
           <a:prstGeom prst="rect">
             <a:avLst/>
@@ -3429,13 +3813,13 @@
           <a:noFill/>
         </p:spPr>
         <p:txBody>
-          <a:bodyPr wrap="none">
+          <a:bodyPr wrap="square">
             <a:spAutoFit/>
           </a:bodyPr>
           <a:lstStyle/>
           <a:p>
             <a:pPr>
-              <a:defRPr sz="2400" b="1">
+              <a:defRPr sz="2200" b="1">
                 <a:solidFill>
                   <a:srgbClr val="F8FAFC"/>
                 </a:solidFill>
@@ -3455,7 +3839,7 @@
         </p:nvSpPr>
         <p:spPr>
           <a:xfrm>
-            <a:off x="731520" y="6217920"/>
+            <a:off x="731520" y="6309360"/>
             <a:ext cx="10698480" cy="365760"/>
           </a:xfrm>
           <a:prstGeom prst="rect">
@@ -3470,28 +3854,73 @@
           <a:lstStyle/>
           <a:p>
             <a:pPr>
-              <a:defRPr sz="1000">
+              <a:defRPr sz="950">
                 <a:solidFill>
                   <a:srgbClr val="94A3B8"/>
                 </a:solidFill>
               </a:defRPr>
             </a:pPr>
             <a:r>
-              <a:t>SpendNest Revenue Intelligence Inbox — Volopay Assessment | Slide 2 of 5</a:t>
-            </a:r>
-          </a:p>
-        </p:txBody>
-      </p:sp>
-      <p:sp>
-        <p:nvSpPr>
-          <p:cNvPr id="5" name="TextBox 4"/>
+              <a:t>SpendNest Revenue Intelligence Inbox  •  Candidate: Dinesh Madhavan M  •  Live: https://volopay-assignment-inqe.onrender.com  •  Slide 2 of 5</a:t>
+            </a:r>
+          </a:p>
+        </p:txBody>
+      </p:sp>
+      <p:sp>
+        <p:nvSpPr>
+          <p:cNvPr id="5" name="Rounded Rectangle 4"/>
+          <p:cNvSpPr/>
+          <p:nvPr/>
+        </p:nvSpPr>
+        <p:spPr>
+          <a:xfrm>
+            <a:off x="731520" y="1371600"/>
+            <a:ext cx="5248656" cy="4754880"/>
+          </a:xfrm>
+          <a:prstGeom prst="roundRect">
+            <a:avLst/>
+          </a:prstGeom>
+          <a:solidFill>
+            <a:srgbClr val="131A2B"/>
+          </a:solidFill>
+          <a:ln w="15240">
+            <a:solidFill>
+              <a:srgbClr val="06B6D4"/>
+            </a:solidFill>
+          </a:ln>
+        </p:spPr>
+        <p:style>
+          <a:lnRef idx="1">
+            <a:schemeClr val="accent1"/>
+          </a:lnRef>
+          <a:fillRef idx="3">
+            <a:schemeClr val="accent1"/>
+          </a:fillRef>
+          <a:effectRef idx="2">
+            <a:schemeClr val="accent1"/>
+          </a:effectRef>
+          <a:fontRef idx="minor">
+            <a:schemeClr val="lt1"/>
+          </a:fontRef>
+        </p:style>
+        <p:txBody>
+          <a:bodyPr rtlCol="0" anchor="ctr"/>
+          <a:lstStyle/>
+          <a:p>
+            <a:pPr algn="ctr"/>
+          </a:p>
+        </p:txBody>
+      </p:sp>
+      <p:sp>
+        <p:nvSpPr>
+          <p:cNvPr id="6" name="TextBox 5"/>
           <p:cNvSpPr txBox="1"/>
           <p:nvPr/>
         </p:nvSpPr>
         <p:spPr>
           <a:xfrm>
-            <a:off x="731520" y="1463040"/>
-            <a:ext cx="10698480" cy="4572000"/>
+            <a:off x="914400" y="1554480"/>
+            <a:ext cx="4882896" cy="4389120"/>
           </a:xfrm>
           <a:prstGeom prst="rect">
             <a:avLst/>
@@ -3506,16 +3935,28 @@
           <a:p>
             <a:pPr>
               <a:spcAft>
-                <a:spcPts val="1400"/>
+                <a:spcPts val="1200"/>
               </a:spcAft>
-              <a:defRPr sz="1300">
-                <a:solidFill>
-                  <a:srgbClr val="94A3B8"/>
-                </a:solidFill>
-              </a:defRPr>
-            </a:pPr>
-            <a:r>
-              <a:t>Manager-Centric UX Design: Prioritize high-signal exceptions, explicit denominators, and evidence drill-down over vanity metric charts.</a:t>
+              <a:defRPr sz="1200" b="1">
+                <a:solidFill>
+                  <a:srgbClr val="06B6D4"/>
+                </a:solidFill>
+              </a:defRPr>
+            </a:pPr>
+            <a:r>
+              <a:t>CORE INTERFACE CHOICES</a:t>
+            </a:r>
+          </a:p>
+          <a:p>
+            <a:pPr>
+              <a:defRPr sz="1200" b="1">
+                <a:solidFill>
+                  <a:srgbClr val="F8FAFC"/>
+                </a:solidFill>
+              </a:defRPr>
+            </a:pPr>
+            <a:r>
+              <a:t>• Executive Left-Sidebar Navigation</a:t>
             </a:r>
           </a:p>
           <a:p>
@@ -3523,14 +3964,26 @@
               <a:spcAft>
                 <a:spcPts val="800"/>
               </a:spcAft>
-              <a:defRPr sz="1400" b="1">
-                <a:solidFill>
-                  <a:srgbClr val="06B6D4"/>
-                </a:solidFill>
-              </a:defRPr>
-            </a:pPr>
-            <a:r>
-              <a:t>Key Interface Decisions:</a:t>
+              <a:defRPr sz="1050">
+                <a:solidFill>
+                  <a:srgbClr val="94A3B8"/>
+                </a:solidFill>
+              </a:defRPr>
+            </a:pPr>
+            <a:r>
+              <a:t>Consolidates Revenue Inbox, Contract Verification, Manager Daily Brief, and Export Center into an accessible SaaS layout.</a:t>
+            </a:r>
+          </a:p>
+          <a:p>
+            <a:pPr>
+              <a:defRPr sz="1200" b="1">
+                <a:solidFill>
+                  <a:srgbClr val="F8FAFC"/>
+                </a:solidFill>
+              </a:defRPr>
+            </a:pPr>
+            <a:r>
+              <a:t>• Built-In 5-Step Contract Replay Simulator</a:t>
             </a:r>
           </a:p>
           <a:p>
@@ -3538,6 +3991,18 @@
               <a:spcAft>
                 <a:spcPts val="800"/>
               </a:spcAft>
+              <a:defRPr sz="1050">
+                <a:solidFill>
+                  <a:srgbClr val="94A3B8"/>
+                </a:solidFill>
+              </a:defRPr>
+            </a:pPr>
+            <a:r>
+              <a:t>Interactive toolbar to test idempotent repeat batch imports, manual route overrides, and late-arriving update batches directly in the UI per DATA_CONTRACT.md.</a:t>
+            </a:r>
+          </a:p>
+          <a:p>
+            <a:pPr>
               <a:defRPr sz="1200" b="1">
                 <a:solidFill>
                   <a:srgbClr val="F8FAFC"/>
@@ -3545,7 +4010,7 @@
               </a:defRPr>
             </a:pPr>
             <a:r>
-              <a:t>• Built-In Replay Simulator Toolbar: 5 interactive buttons to test idempotent repeat imports, manual route overrides, and late-arriving update batches directly in the UI.</a:t>
+              <a:t>• Strict Mathematical Denominators</a:t>
             </a:r>
           </a:p>
           <a:p>
@@ -3553,6 +4018,18 @@
               <a:spcAft>
                 <a:spcPts val="800"/>
               </a:spcAft>
+              <a:defRPr sz="1050">
+                <a:solidFill>
+                  <a:srgbClr val="94A3B8"/>
+                </a:solidFill>
+              </a:defRPr>
+            </a:pPr>
+            <a:r>
+              <a:t>Separates Call Reps (SDRs/AEs dialing) from Meeting Organizers (calendar coordinators). Transcript coverage explicitly calculated against all 44 selected records.</a:t>
+            </a:r>
+          </a:p>
+          <a:p>
+            <a:pPr>
               <a:defRPr sz="1200" b="1">
                 <a:solidFill>
                   <a:srgbClr val="F8FAFC"/>
@@ -3560,7 +4037,7 @@
               </a:defRPr>
             </a:pPr>
             <a:r>
-              <a:t>• Strict Mathematical Denominators: Separates Call Reps (SDRs/AEs dialing) from Meeting Organizers (calendar coordinators). Transcript coverage explicitly measured over all 44 selected records.</a:t>
+              <a:t>• Slide-Out Deep Evidence Inspection Drawer</a:t>
             </a:r>
           </a:p>
           <a:p>
@@ -3568,62 +4045,205 @@
               <a:spcAft>
                 <a:spcPts val="800"/>
               </a:spcAft>
+              <a:defRPr sz="1050">
+                <a:solidFill>
+                  <a:srgbClr val="94A3B8"/>
+                </a:solidFill>
+              </a:defRPr>
+            </a:pPr>
+            <a:r>
+              <a:t>Clicking any interaction slides out formatted dialogue turns with exact timecodes, verbatim evidence quotes, limitations, and assigned action owners.</a:t>
+            </a:r>
+          </a:p>
+        </p:txBody>
+      </p:sp>
+      <p:sp>
+        <p:nvSpPr>
+          <p:cNvPr id="7" name="Rounded Rectangle 6"/>
+          <p:cNvSpPr/>
+          <p:nvPr/>
+        </p:nvSpPr>
+        <p:spPr>
+          <a:xfrm>
+            <a:off x="6199632" y="1371600"/>
+            <a:ext cx="5248656" cy="4754880"/>
+          </a:xfrm>
+          <a:prstGeom prst="roundRect">
+            <a:avLst/>
+          </a:prstGeom>
+          <a:solidFill>
+            <a:srgbClr val="131A2B"/>
+          </a:solidFill>
+          <a:ln w="15240">
+            <a:solidFill>
+              <a:srgbClr val="F59E0B"/>
+            </a:solidFill>
+          </a:ln>
+        </p:spPr>
+        <p:style>
+          <a:lnRef idx="1">
+            <a:schemeClr val="accent1"/>
+          </a:lnRef>
+          <a:fillRef idx="3">
+            <a:schemeClr val="accent1"/>
+          </a:fillRef>
+          <a:effectRef idx="2">
+            <a:schemeClr val="accent1"/>
+          </a:effectRef>
+          <a:fontRef idx="minor">
+            <a:schemeClr val="lt1"/>
+          </a:fontRef>
+        </p:style>
+        <p:txBody>
+          <a:bodyPr rtlCol="0" anchor="ctr"/>
+          <a:lstStyle/>
+          <a:p>
+            <a:pPr algn="ctr"/>
+          </a:p>
+        </p:txBody>
+      </p:sp>
+      <p:sp>
+        <p:nvSpPr>
+          <p:cNvPr id="8" name="TextBox 7"/>
+          <p:cNvSpPr txBox="1"/>
+          <p:nvPr/>
+        </p:nvSpPr>
+        <p:spPr>
+          <a:xfrm>
+            <a:off x="6400800" y="1554480"/>
+            <a:ext cx="4882896" cy="4389120"/>
+          </a:xfrm>
+          <a:prstGeom prst="rect">
+            <a:avLst/>
+          </a:prstGeom>
+          <a:noFill/>
+        </p:spPr>
+        <p:txBody>
+          <a:bodyPr wrap="square">
+            <a:spAutoFit/>
+          </a:bodyPr>
+          <a:lstStyle/>
+          <a:p>
+            <a:pPr>
+              <a:spcAft>
+                <a:spcPts val="1200"/>
+              </a:spcAft>
               <a:defRPr sz="1200" b="1">
                 <a:solidFill>
-                  <a:srgbClr val="F8FAFC"/>
-                </a:solidFill>
-              </a:defRPr>
-            </a:pPr>
-            <a:r>
-              <a:t>• Deep Evidence Drawer with Formatted Turns: Allows inspecting verbatim turns, elapsed timecodes, quotes, limitations, and assigned action owners behind every recommendation.</a:t>
-            </a:r>
-          </a:p>
-          <a:p>
-            <a:pPr>
-              <a:spcBef>
-                <a:spcPts val="1000"/>
-              </a:spcBef>
+                  <a:srgbClr val="F59E0B"/>
+                </a:solidFill>
+              </a:defRPr>
+            </a:pPr>
+            <a:r>
+              <a:t>DELIBERATE OMISSIONS (ENGINEERING DISCIPLINE)</a:t>
+            </a:r>
+          </a:p>
+          <a:p>
+            <a:pPr>
+              <a:defRPr sz="1200" b="1">
+                <a:solidFill>
+                  <a:srgbClr val="F59E0B"/>
+                </a:solidFill>
+              </a:defRPr>
+            </a:pPr>
+            <a:r>
+              <a:t>✕ Zero Fabricated Summaries for Silent Records</a:t>
+            </a:r>
+          </a:p>
+          <a:p>
+            <a:pPr>
               <a:spcAft>
                 <a:spcPts val="800"/>
               </a:spcAft>
-              <a:defRPr sz="1400" b="1">
+              <a:defRPr sz="1050">
+                <a:solidFill>
+                  <a:srgbClr val="94A3B8"/>
+                </a:solidFill>
+              </a:defRPr>
+            </a:pPr>
+            <a:r>
+              <a:t>For the 26 records with null transcripts or empty turns, we deliberately refused to hallucinate synthetic summaries. They are logged honestly as 'Intake / No Audio Supplied'.</a:t>
+            </a:r>
+          </a:p>
+          <a:p>
+            <a:pPr>
+              <a:defRPr sz="1200" b="1">
                 <a:solidFill>
                   <a:srgbClr val="F59E0B"/>
                 </a:solidFill>
               </a:defRPr>
             </a:pPr>
             <a:r>
-              <a:t>Deliberate Omissions (Design Discipline):</a:t>
+              <a:t>✕ No Standalone Date Filter</a:t>
             </a:r>
           </a:p>
           <a:p>
             <a:pPr>
               <a:spcAft>
-                <a:spcPts val="600"/>
+                <a:spcPts val="800"/>
               </a:spcAft>
+              <a:defRPr sz="1050">
+                <a:solidFill>
+                  <a:srgbClr val="94A3B8"/>
+                </a:solidFill>
+              </a:defRPr>
+            </a:pPr>
+            <a:r>
+              <a:t>All supplied records fall on Friday, 21 August 2026 (Asia/Kolkata). Providing a date picker adds zero analytical value and was omitted per brief instructions.</a:t>
+            </a:r>
+          </a:p>
+          <a:p>
+            <a:pPr>
               <a:defRPr sz="1200" b="1">
                 <a:solidFill>
-                  <a:srgbClr val="F8FAFC"/>
-                </a:solidFill>
-              </a:defRPr>
-            </a:pPr>
-            <a:r>
-              <a:t>• Zero Fabricated Summaries: For the 26 records with null transcripts or empty turns, we deliberately declined to generate fake summaries. They are logged transparently as Intake / No Audio Supplied.</a:t>
+                  <a:srgbClr val="F59E0B"/>
+                </a:solidFill>
+              </a:defRPr>
+            </a:pPr>
+            <a:r>
+              <a:t>✕ No Speculative Pipeline / ARR Guessing</a:t>
             </a:r>
           </a:p>
           <a:p>
             <a:pPr>
               <a:spcAft>
-                <a:spcPts val="600"/>
+                <a:spcPts val="800"/>
               </a:spcAft>
+              <a:defRPr sz="1050">
+                <a:solidFill>
+                  <a:srgbClr val="94A3B8"/>
+                </a:solidFill>
+              </a:defRPr>
+            </a:pPr>
+            <a:r>
+              <a:t>The brief forbids inventing pipeline value that data does not establish. We show verified commercial volume (e.g. Asterloom INR 26-39L/mo) without guessing fictitious ARR.</a:t>
+            </a:r>
+          </a:p>
+          <a:p>
+            <a:pPr>
               <a:defRPr sz="1200" b="1">
                 <a:solidFill>
-                  <a:srgbClr val="F8FAFC"/>
-                </a:solidFill>
-              </a:defRPr>
-            </a:pPr>
-            <a:r>
-              <a:t>• No Standalone Date Filter: All supplied interactions fall on 21 August 2026 (Asia/Kolkata). Providing a date picker adds zero analytical value and was omitted.</a:t>
+                  <a:srgbClr val="F59E0B"/>
+                </a:solidFill>
+              </a:defRPr>
+            </a:pPr>
+            <a:r>
+              <a:t>✕ No Authentication / Login Barriers</a:t>
+            </a:r>
+          </a:p>
+          <a:p>
+            <a:pPr>
+              <a:spcAft>
+                <a:spcPts val="800"/>
+              </a:spcAft>
+              <a:defRPr sz="1050">
+                <a:solidFill>
+                  <a:srgbClr val="94A3B8"/>
+                </a:solidFill>
+              </a:defRPr>
+            </a:pPr>
+            <a:r>
+              <a:t>In accordance with ASSIGNMENT.md line 86, we omitted passwords and external API keys so reviewers can evaluate the workspace instantly with zero configuration.</a:t>
             </a:r>
           </a:p>
         </p:txBody>
@@ -3662,8 +4282,8 @@
         </p:nvSpPr>
         <p:spPr>
           <a:xfrm>
-            <a:off x="731520" y="457200"/>
-            <a:ext cx="10698480" cy="365760"/>
+            <a:off x="731520" y="365760"/>
+            <a:ext cx="10698480" cy="320040"/>
           </a:xfrm>
           <a:prstGeom prst="rect">
             <a:avLst/>
@@ -3671,20 +4291,20 @@
           <a:noFill/>
         </p:spPr>
         <p:txBody>
-          <a:bodyPr wrap="none">
+          <a:bodyPr wrap="square">
             <a:spAutoFit/>
           </a:bodyPr>
           <a:lstStyle/>
           <a:p>
             <a:pPr>
-              <a:defRPr sz="1100" b="1">
+              <a:defRPr sz="1000" b="1">
                 <a:solidFill>
                   <a:srgbClr val="06B6D4"/>
                 </a:solidFill>
               </a:defRPr>
             </a:pPr>
             <a:r>
-              <a:t>SLIDE 3 • ROUTING ARCHITECTURE &amp; DIFFICULT DECISION</a:t>
+              <a:t>VOLOPAY EVALUATION  •  SLIDE 3 • ROUTING TAXONOMY &amp; DIFFICULT CASE</a:t>
             </a:r>
           </a:p>
         </p:txBody>
@@ -3697,8 +4317,8 @@
         </p:nvSpPr>
         <p:spPr>
           <a:xfrm>
-            <a:off x="731520" y="777240"/>
-            <a:ext cx="10698480" cy="640080"/>
+            <a:off x="731520" y="685800"/>
+            <a:ext cx="10698480" cy="594360"/>
           </a:xfrm>
           <a:prstGeom prst="rect">
             <a:avLst/>
@@ -3706,20 +4326,20 @@
           <a:noFill/>
         </p:spPr>
         <p:txBody>
-          <a:bodyPr wrap="none">
+          <a:bodyPr wrap="square">
             <a:spAutoFit/>
           </a:bodyPr>
           <a:lstStyle/>
           <a:p>
             <a:pPr>
-              <a:defRPr sz="2400" b="1">
+              <a:defRPr sz="2200" b="1">
                 <a:solidFill>
                   <a:srgbClr val="F8FAFC"/>
                 </a:solidFill>
               </a:defRPr>
             </a:pPr>
             <a:r>
-              <a:t>3. Routing Taxonomy &amp; The Difficult Case (M07)</a:t>
+              <a:t>3. Routing Taxonomy &amp; The Difficult Case: Willowfield Trust (M07)</a:t>
             </a:r>
           </a:p>
         </p:txBody>
@@ -3732,7 +4352,7 @@
         </p:nvSpPr>
         <p:spPr>
           <a:xfrm>
-            <a:off x="731520" y="6217920"/>
+            <a:off x="731520" y="6309360"/>
             <a:ext cx="10698480" cy="365760"/>
           </a:xfrm>
           <a:prstGeom prst="rect">
@@ -3747,28 +4367,73 @@
           <a:lstStyle/>
           <a:p>
             <a:pPr>
-              <a:defRPr sz="1000">
+              <a:defRPr sz="950">
                 <a:solidFill>
                   <a:srgbClr val="94A3B8"/>
                 </a:solidFill>
               </a:defRPr>
             </a:pPr>
             <a:r>
-              <a:t>SpendNest Revenue Intelligence Inbox — Volopay Assessment | Slide 3 of 5</a:t>
-            </a:r>
-          </a:p>
-        </p:txBody>
-      </p:sp>
-      <p:sp>
-        <p:nvSpPr>
-          <p:cNvPr id="5" name="TextBox 4"/>
+              <a:t>SpendNest Revenue Intelligence Inbox  •  Candidate: Dinesh Madhavan M  •  Live: https://volopay-assignment-inqe.onrender.com  •  Slide 3 of 5</a:t>
+            </a:r>
+          </a:p>
+        </p:txBody>
+      </p:sp>
+      <p:sp>
+        <p:nvSpPr>
+          <p:cNvPr id="5" name="Rounded Rectangle 4"/>
+          <p:cNvSpPr/>
+          <p:nvPr/>
+        </p:nvSpPr>
+        <p:spPr>
+          <a:xfrm>
+            <a:off x="731520" y="1371600"/>
+            <a:ext cx="5248656" cy="4754880"/>
+          </a:xfrm>
+          <a:prstGeom prst="roundRect">
+            <a:avLst/>
+          </a:prstGeom>
+          <a:solidFill>
+            <a:srgbClr val="131A2B"/>
+          </a:solidFill>
+          <a:ln w="15240">
+            <a:solidFill>
+              <a:srgbClr val="10B981"/>
+            </a:solidFill>
+          </a:ln>
+        </p:spPr>
+        <p:style>
+          <a:lnRef idx="1">
+            <a:schemeClr val="accent1"/>
+          </a:lnRef>
+          <a:fillRef idx="3">
+            <a:schemeClr val="accent1"/>
+          </a:fillRef>
+          <a:effectRef idx="2">
+            <a:schemeClr val="accent1"/>
+          </a:effectRef>
+          <a:fontRef idx="minor">
+            <a:schemeClr val="lt1"/>
+          </a:fontRef>
+        </p:style>
+        <p:txBody>
+          <a:bodyPr rtlCol="0" anchor="ctr"/>
+          <a:lstStyle/>
+          <a:p>
+            <a:pPr algn="ctr"/>
+          </a:p>
+        </p:txBody>
+      </p:sp>
+      <p:sp>
+        <p:nvSpPr>
+          <p:cNvPr id="6" name="TextBox 5"/>
           <p:cNvSpPr txBox="1"/>
           <p:nvPr/>
         </p:nvSpPr>
         <p:spPr>
           <a:xfrm>
-            <a:off x="731520" y="1463040"/>
-            <a:ext cx="10698480" cy="4572000"/>
+            <a:off x="914400" y="1554480"/>
+            <a:ext cx="4882896" cy="4389120"/>
           </a:xfrm>
           <a:prstGeom prst="rect">
             <a:avLst/>
@@ -3785,142 +4450,375 @@
               <a:spcAft>
                 <a:spcPts val="1000"/>
               </a:spcAft>
-              <a:defRPr sz="1400" b="1">
+              <a:defRPr sz="1200" b="1">
                 <a:solidFill>
                   <a:srgbClr val="10B981"/>
                 </a:solidFill>
               </a:defRPr>
             </a:pPr>
             <a:r>
-              <a:t>Action-Oriented Routing Taxonomy (6 Distinct Operational Destinations):</a:t>
+              <a:t>OPERATIONAL ROUTING TAXONOMY</a:t>
+            </a:r>
+          </a:p>
+          <a:p>
+            <a:pPr>
+              <a:defRPr sz="1150" b="1">
+                <a:solidFill>
+                  <a:srgbClr val="F8FAFC"/>
+                </a:solidFill>
+              </a:defRPr>
+            </a:pPr>
+            <a:r>
+              <a:t>1. Deal Next Steps / Pipeline</a:t>
             </a:r>
           </a:p>
           <a:p>
             <a:pPr>
               <a:spcAft>
-                <a:spcPts val="400"/>
+                <a:spcPts val="500"/>
               </a:spcAft>
-              <a:defRPr sz="1100" b="1">
+              <a:defRPr sz="1000">
+                <a:solidFill>
+                  <a:srgbClr val="94A3B8"/>
+                </a:solidFill>
+              </a:defRPr>
+            </a:pPr>
+            <a:r>
+              <a:t>Active commercial evaluations with stated pricing/budget (M03 Asterloom, C03 Milan API, C08 Raghav referral).</a:t>
+            </a:r>
+          </a:p>
+          <a:p>
+            <a:pPr>
+              <a:defRPr sz="1150" b="1">
                 <a:solidFill>
                   <a:srgbClr val="F8FAFC"/>
                 </a:solidFill>
               </a:defRPr>
             </a:pPr>
             <a:r>
-              <a:t>1. Deal Next Steps / Pipeline — Active commercial evaluations with stated pricing/budget (M03 Asterloom Systems, C03 Milan API, C08 Raghav referral).</a:t>
+              <a:t>2. Customer Success / Bug Escalation</a:t>
             </a:r>
           </a:p>
           <a:p>
             <a:pPr>
               <a:spcAft>
-                <a:spcPts val="400"/>
+                <a:spcPts val="500"/>
               </a:spcAft>
-              <a:defRPr sz="1100" b="1">
+              <a:defRPr sz="1000">
+                <a:solidFill>
+                  <a:srgbClr val="94A3B8"/>
+                </a:solidFill>
+              </a:defRPr>
+            </a:pPr>
+            <a:r>
+              <a:t>Urgent software defects &amp; account migrations (M07 Willowfield Trust, M04 Cedarwave).</a:t>
+            </a:r>
+          </a:p>
+          <a:p>
+            <a:pPr>
+              <a:defRPr sz="1150" b="1">
                 <a:solidFill>
                   <a:srgbClr val="F8FAFC"/>
                 </a:solidFill>
               </a:defRPr>
             </a:pPr>
             <a:r>
-              <a:t>2. Customer Success / Escalations — Urgent customer bug escalations and account migrations (M07 Willowfield Trust, M04 Cedarwave Distribution).</a:t>
+              <a:t>3. Partnerships / Channel Advisory</a:t>
             </a:r>
           </a:p>
           <a:p>
             <a:pPr>
               <a:spcAft>
-                <a:spcPts val="400"/>
+                <a:spcPts val="500"/>
               </a:spcAft>
-              <a:defRPr sz="1100" b="1">
+              <a:defRPr sz="1000">
+                <a:solidFill>
+                  <a:srgbClr val="94A3B8"/>
+                </a:solidFill>
+              </a:defRPr>
+            </a:pPr>
+            <a:r>
+              <a:t>Referral partners incorporating overseas businesses (C07 Willowbank Advisory, M01 Harborpath).</a:t>
+            </a:r>
+          </a:p>
+          <a:p>
+            <a:pPr>
+              <a:defRPr sz="1150" b="1">
                 <a:solidFill>
                   <a:srgbClr val="F8FAFC"/>
                 </a:solidFill>
               </a:defRPr>
             </a:pPr>
             <a:r>
-              <a:t>3. Partnerships / Channel Advisory — Referral partners incorporating overseas businesses (C07 Willowbank Advisory, M01 Harborpath Advisory).</a:t>
+              <a:t>4. Vendor &amp; Internal Enablement</a:t>
             </a:r>
           </a:p>
           <a:p>
             <a:pPr>
               <a:spcAft>
-                <a:spcPts val="400"/>
+                <a:spcPts val="500"/>
               </a:spcAft>
-              <a:defRPr sz="1100" b="1">
+              <a:defRPr sz="1000">
+                <a:solidFill>
+                  <a:srgbClr val="94A3B8"/>
+                </a:solidFill>
+              </a:defRPr>
+            </a:pPr>
+            <a:r>
+              <a:t>Procurement reviews (M02 LedgerBridge) &amp; internal staff training (M10 Billing walkthrough).</a:t>
+            </a:r>
+          </a:p>
+          <a:p>
+            <a:pPr>
+              <a:defRPr sz="1150" b="1">
                 <a:solidFill>
                   <a:srgbClr val="F8FAFC"/>
                 </a:solidFill>
               </a:defRPr>
             </a:pPr>
             <a:r>
-              <a:t>4. Vendor &amp; Internal Enablement — Procurement reviews (M02 LedgerBridge) &amp; internal staff training (M10 Billing walkthrough).</a:t>
+              <a:t>5. Low Priority / Voicemail</a:t>
             </a:r>
           </a:p>
           <a:p>
             <a:pPr>
               <a:spcAft>
-                <a:spcPts val="400"/>
+                <a:spcPts val="500"/>
               </a:spcAft>
-              <a:defRPr sz="1100" b="1">
+              <a:defRPr sz="1000">
+                <a:solidFill>
+                  <a:srgbClr val="94A3B8"/>
+                </a:solidFill>
+              </a:defRPr>
+            </a:pPr>
+            <a:r>
+              <a:t>Gatekeeper transfers, voicemails, and short unreachables (C01, C02, C04, C06, C10).</a:t>
+            </a:r>
+          </a:p>
+          <a:p>
+            <a:pPr>
+              <a:defRPr sz="1150" b="1">
                 <a:solidFill>
                   <a:srgbClr val="F8FAFC"/>
                 </a:solidFill>
               </a:defRPr>
             </a:pPr>
             <a:r>
-              <a:t>5. Low Priority / Voicemail / Gatekeeper — Gatekeeper transfers and voicemails (C01, C02, C04, C06, C10).</a:t>
+              <a:t>6. Intake / No Audio Supplied</a:t>
             </a:r>
           </a:p>
           <a:p>
             <a:pPr>
               <a:spcAft>
-                <a:spcPts val="400"/>
+                <a:spcPts val="500"/>
               </a:spcAft>
-              <a:defRPr sz="1100" b="1">
+              <a:defRPr sz="1000">
+                <a:solidFill>
+                  <a:srgbClr val="94A3B8"/>
+                </a:solidFill>
+              </a:defRPr>
+            </a:pPr>
+            <a:r>
+              <a:t>Short background dials &amp; empty meetings awaiting audio (B01-B20, M05, M08, M11-M14).</a:t>
+            </a:r>
+          </a:p>
+        </p:txBody>
+      </p:sp>
+      <p:sp>
+        <p:nvSpPr>
+          <p:cNvPr id="7" name="Rounded Rectangle 6"/>
+          <p:cNvSpPr/>
+          <p:nvPr/>
+        </p:nvSpPr>
+        <p:spPr>
+          <a:xfrm>
+            <a:off x="6199632" y="1371600"/>
+            <a:ext cx="5248656" cy="4754880"/>
+          </a:xfrm>
+          <a:prstGeom prst="roundRect">
+            <a:avLst/>
+          </a:prstGeom>
+          <a:solidFill>
+            <a:srgbClr val="131A2B"/>
+          </a:solidFill>
+          <a:ln w="15240">
+            <a:solidFill>
+              <a:srgbClr val="EF4444"/>
+            </a:solidFill>
+          </a:ln>
+        </p:spPr>
+        <p:style>
+          <a:lnRef idx="1">
+            <a:schemeClr val="accent1"/>
+          </a:lnRef>
+          <a:fillRef idx="3">
+            <a:schemeClr val="accent1"/>
+          </a:fillRef>
+          <a:effectRef idx="2">
+            <a:schemeClr val="accent1"/>
+          </a:effectRef>
+          <a:fontRef idx="minor">
+            <a:schemeClr val="lt1"/>
+          </a:fontRef>
+        </p:style>
+        <p:txBody>
+          <a:bodyPr rtlCol="0" anchor="ctr"/>
+          <a:lstStyle/>
+          <a:p>
+            <a:pPr algn="ctr"/>
+          </a:p>
+        </p:txBody>
+      </p:sp>
+      <p:sp>
+        <p:nvSpPr>
+          <p:cNvPr id="8" name="TextBox 7"/>
+          <p:cNvSpPr txBox="1"/>
+          <p:nvPr/>
+        </p:nvSpPr>
+        <p:spPr>
+          <a:xfrm>
+            <a:off x="6400800" y="1554480"/>
+            <a:ext cx="4882896" cy="4389120"/>
+          </a:xfrm>
+          <a:prstGeom prst="rect">
+            <a:avLst/>
+          </a:prstGeom>
+          <a:noFill/>
+        </p:spPr>
+        <p:txBody>
+          <a:bodyPr wrap="square">
+            <a:spAutoFit/>
+          </a:bodyPr>
+          <a:lstStyle/>
+          <a:p>
+            <a:pPr>
+              <a:spcAft>
+                <a:spcPts val="1000"/>
+              </a:spcAft>
+              <a:defRPr sz="1200" b="1">
+                <a:solidFill>
+                  <a:srgbClr val="EF4444"/>
+                </a:solidFill>
+              </a:defRPr>
+            </a:pPr>
+            <a:r>
+              <a:t>THE DIFFICULT CASE: WILLOWFIELD TRUST (M07)</a:t>
+            </a:r>
+          </a:p>
+          <a:p>
+            <a:pPr>
+              <a:defRPr sz="1150" b="1">
                 <a:solidFill>
                   <a:srgbClr val="F8FAFC"/>
                 </a:solidFill>
               </a:defRPr>
             </a:pPr>
             <a:r>
-              <a:t>6. Intake / Unreviewed — Short dials &amp; empty meetings awaiting audio (B01-B20, M05, M08, M11-M14).</a:t>
-            </a:r>
-          </a:p>
-          <a:p>
-            <a:pPr>
-              <a:spcBef>
-                <a:spcPts val="1200"/>
-              </a:spcBef>
+              <a:t>• Delivery Batch 1 State (Revision 1)</a:t>
+            </a:r>
+          </a:p>
+          <a:p>
+            <a:pPr>
               <a:spcAft>
-                <a:spcPts val="600"/>
+                <a:spcPts val="700"/>
               </a:spcAft>
-              <a:defRPr sz="1400" b="1">
-                <a:solidFill>
-                  <a:srgbClr val="EF4444"/>
-                </a:solidFill>
-              </a:defRPr>
-            </a:pPr>
-            <a:r>
-              <a:t>The Difficult Routing Case: Willowfield Trust (M07)</a:t>
-            </a:r>
-          </a:p>
-          <a:p>
-            <a:pPr>
-              <a:defRPr sz="1100">
+              <a:defRPr sz="1000">
                 <a:solidFill>
                   <a:srgbClr val="94A3B8"/>
                 </a:solidFill>
               </a:defRPr>
             </a:pPr>
             <a:r>
-              <a:t>• In Delivery Batch 1, M07 arrived with null turns and was provisionally labeled as an unreviewed routine check-in.</a:t>
+              <a:t>Arrived with null speech turns and unavailable_reason: 'Transcript withheld in initial delivery batch'. Provisionally assigned to Intake / Routine check-in.</a:t>
+            </a:r>
+          </a:p>
+          <a:p>
+            <a:pPr>
+              <a:defRPr sz="1150" b="1">
+                <a:solidFill>
+                  <a:srgbClr val="F8FAFC"/>
+                </a:solidFill>
+              </a:defRPr>
+            </a:pPr>
+            <a:r>
+              <a:t>• Delivery Batch 2 Update (Revision 2)</a:t>
+            </a:r>
+          </a:p>
+          <a:p>
+            <a:pPr>
+              <a:spcAft>
+                <a:spcPts val="700"/>
+              </a:spcAft>
+              <a:defRPr sz="1000">
+                <a:solidFill>
+                  <a:srgbClr val="94A3B8"/>
+                </a:solidFill>
+              </a:defRPr>
+            </a:pPr>
+            <a:r>
+              <a:t>Arrived with 27 speech turns. During screen-share, Customer A demonstrated critical software bugs:</a:t>
             </a:r>
             <a:br/>
             <a:r>
-              <a:t>• In Delivery Batch 2 (Rev 2), 27 turns arrived showing Customer A screen-sharing critical software defects: 1) payment description edits reverting upon save, and 2) document upload failing when recreating payments.</a:t>
+              <a:t>• Turn 2 &amp; 3: Editing event payment descriptions reverts upon clicking 'Save changes'.</a:t>
             </a:r>
             <a:br/>
             <a:r>
-              <a:t>• Decision: Shifted immediately from Routine Check-in to Customer Success / Bug Escalation. Under DATA_CONTRACT.md, manager overrides survive batch replays and browser reloads.</a:t>
+              <a:t>• Turn 8: Document upload fails when recreating a payment.</a:t>
+            </a:r>
+          </a:p>
+          <a:p>
+            <a:pPr>
+              <a:defRPr sz="1150" b="1">
+                <a:solidFill>
+                  <a:srgbClr val="F8FAFC"/>
+                </a:solidFill>
+              </a:defRPr>
+            </a:pPr>
+            <a:r>
+              <a:t>• Manager Decision &amp; Routing Shift</a:t>
+            </a:r>
+          </a:p>
+          <a:p>
+            <a:pPr>
+              <a:spcAft>
+                <a:spcPts val="700"/>
+              </a:spcAft>
+              <a:defRPr sz="1000">
+                <a:solidFill>
+                  <a:srgbClr val="94A3B8"/>
+                </a:solidFill>
+              </a:defRPr>
+            </a:pPr>
+            <a:r>
+              <a:t>Shifted immediately from routine check-in to 'Customer Success / Bug Escalation' with urgent engineering follow-up assigned to Arun.</a:t>
+            </a:r>
+          </a:p>
+          <a:p>
+            <a:pPr>
+              <a:defRPr sz="1150" b="1">
+                <a:solidFill>
+                  <a:srgbClr val="F8FAFC"/>
+                </a:solidFill>
+              </a:defRPr>
+            </a:pPr>
+            <a:r>
+              <a:t>• Preserved Manual Override Contract</a:t>
+            </a:r>
+          </a:p>
+          <a:p>
+            <a:pPr>
+              <a:spcAft>
+                <a:spcPts val="700"/>
+              </a:spcAft>
+              <a:defRPr sz="1000">
+                <a:solidFill>
+                  <a:srgbClr val="94A3B8"/>
+                </a:solidFill>
+              </a:defRPr>
+            </a:pPr>
+            <a:r>
+              <a:t>Under DATA_CONTRACT.md, a manager's manual override applied in Step 3 survives Step 4 late updates, Step 5 batch replays, and full browser restarts via persistent localStorage.</a:t>
             </a:r>
           </a:p>
         </p:txBody>
@@ -3959,8 +4857,8 @@
         </p:nvSpPr>
         <p:spPr>
           <a:xfrm>
-            <a:off x="731520" y="457200"/>
-            <a:ext cx="10698480" cy="365760"/>
+            <a:off x="731520" y="365760"/>
+            <a:ext cx="10698480" cy="320040"/>
           </a:xfrm>
           <a:prstGeom prst="rect">
             <a:avLst/>
@@ -3968,20 +4866,20 @@
           <a:noFill/>
         </p:spPr>
         <p:txBody>
-          <a:bodyPr wrap="none">
+          <a:bodyPr wrap="square">
             <a:spAutoFit/>
           </a:bodyPr>
           <a:lstStyle/>
           <a:p>
             <a:pPr>
-              <a:defRPr sz="1100" b="1">
+              <a:defRPr sz="1000" b="1">
                 <a:solidFill>
                   <a:srgbClr val="06B6D4"/>
                 </a:solidFill>
               </a:defRPr>
             </a:pPr>
             <a:r>
-              <a:t>SLIDE 4 • AUDIT TRAIL &amp; REPLAY VERIFICATION</a:t>
+              <a:t>VOLOPAY EVALUATION  •  SLIDE 4 • REPLAY TESTS &amp; DATA CONTRACT AUDIT</a:t>
             </a:r>
           </a:p>
         </p:txBody>
@@ -3994,8 +4892,8 @@
         </p:nvSpPr>
         <p:spPr>
           <a:xfrm>
-            <a:off x="731520" y="777240"/>
-            <a:ext cx="10698480" cy="640080"/>
+            <a:off x="731520" y="685800"/>
+            <a:ext cx="10698480" cy="594360"/>
           </a:xfrm>
           <a:prstGeom prst="rect">
             <a:avLst/>
@@ -4003,20 +4901,20 @@
           <a:noFill/>
         </p:spPr>
         <p:txBody>
-          <a:bodyPr wrap="none">
+          <a:bodyPr wrap="square">
             <a:spAutoFit/>
           </a:bodyPr>
           <a:lstStyle/>
           <a:p>
             <a:pPr>
-              <a:defRPr sz="2400" b="1">
+              <a:defRPr sz="2200" b="1">
                 <a:solidFill>
                   <a:srgbClr val="F8FAFC"/>
                 </a:solidFill>
               </a:defRPr>
             </a:pPr>
             <a:r>
-              <a:t>4. Audit Verification of Key Numbers &amp; Claims</a:t>
+              <a:t>4. Mathematical Audit Verification of Key Numbers &amp; Idempotence</a:t>
             </a:r>
           </a:p>
         </p:txBody>
@@ -4029,7 +4927,7 @@
         </p:nvSpPr>
         <p:spPr>
           <a:xfrm>
-            <a:off x="731520" y="6217920"/>
+            <a:off x="731520" y="6309360"/>
             <a:ext cx="10698480" cy="365760"/>
           </a:xfrm>
           <a:prstGeom prst="rect">
@@ -4044,28 +4942,73 @@
           <a:lstStyle/>
           <a:p>
             <a:pPr>
-              <a:defRPr sz="1000">
+              <a:defRPr sz="950">
                 <a:solidFill>
                   <a:srgbClr val="94A3B8"/>
                 </a:solidFill>
               </a:defRPr>
             </a:pPr>
             <a:r>
-              <a:t>SpendNest Revenue Intelligence Inbox — Volopay Assessment | Slide 4 of 5</a:t>
-            </a:r>
-          </a:p>
-        </p:txBody>
-      </p:sp>
-      <p:sp>
-        <p:nvSpPr>
-          <p:cNvPr id="5" name="TextBox 4"/>
+              <a:t>SpendNest Revenue Intelligence Inbox  •  Candidate: Dinesh Madhavan M  •  Live: https://volopay-assignment-inqe.onrender.com  •  Slide 4 of 5</a:t>
+            </a:r>
+          </a:p>
+        </p:txBody>
+      </p:sp>
+      <p:sp>
+        <p:nvSpPr>
+          <p:cNvPr id="5" name="Rounded Rectangle 4"/>
+          <p:cNvSpPr/>
+          <p:nvPr/>
+        </p:nvSpPr>
+        <p:spPr>
+          <a:xfrm>
+            <a:off x="731520" y="1371600"/>
+            <a:ext cx="2542032" cy="2103120"/>
+          </a:xfrm>
+          <a:prstGeom prst="roundRect">
+            <a:avLst/>
+          </a:prstGeom>
+          <a:solidFill>
+            <a:srgbClr val="131A2B"/>
+          </a:solidFill>
+          <a:ln w="15240">
+            <a:solidFill>
+              <a:srgbClr val="06B6D4"/>
+            </a:solidFill>
+          </a:ln>
+        </p:spPr>
+        <p:style>
+          <a:lnRef idx="1">
+            <a:schemeClr val="accent1"/>
+          </a:lnRef>
+          <a:fillRef idx="3">
+            <a:schemeClr val="accent1"/>
+          </a:fillRef>
+          <a:effectRef idx="2">
+            <a:schemeClr val="accent1"/>
+          </a:effectRef>
+          <a:fontRef idx="minor">
+            <a:schemeClr val="lt1"/>
+          </a:fontRef>
+        </p:style>
+        <p:txBody>
+          <a:bodyPr rtlCol="0" anchor="ctr"/>
+          <a:lstStyle/>
+          <a:p>
+            <a:pPr algn="ctr"/>
+          </a:p>
+        </p:txBody>
+      </p:sp>
+      <p:sp>
+        <p:nvSpPr>
+          <p:cNvPr id="6" name="TextBox 5"/>
           <p:cNvSpPr txBox="1"/>
           <p:nvPr/>
         </p:nvSpPr>
         <p:spPr>
           <a:xfrm>
-            <a:off x="731520" y="1463040"/>
-            <a:ext cx="10698480" cy="4572000"/>
+            <a:off x="841248" y="1508760"/>
+            <a:ext cx="2322576" cy="1828800"/>
           </a:xfrm>
           <a:prstGeom prst="rect">
             <a:avLst/>
@@ -4079,107 +5022,520 @@
           <a:lstStyle/>
           <a:p>
             <a:pPr>
+              <a:defRPr sz="1600" b="1">
+                <a:solidFill>
+                  <a:srgbClr val="06B6D4"/>
+                </a:solidFill>
+              </a:defRPr>
+            </a:pPr>
+            <a:r>
+              <a:t>44 Total Records</a:t>
+            </a:r>
+          </a:p>
+          <a:p>
+            <a:pPr>
               <a:spcAft>
-                <a:spcPts val="1200"/>
+                <a:spcPts val="400"/>
               </a:spcAft>
-              <a:defRPr sz="1400" b="1">
-                <a:solidFill>
-                  <a:srgbClr val="06B6D4"/>
-                </a:solidFill>
-              </a:defRPr>
-            </a:pPr>
-            <a:r>
-              <a:t>Mathematical Verification Against 01_initial.json and 02_update.json:</a:t>
+              <a:defRPr sz="1050" b="1">
+                <a:solidFill>
+                  <a:srgbClr val="F8FAFC"/>
+                </a:solidFill>
+              </a:defRPr>
+            </a:pPr>
+            <a:r>
+              <a:t>Unique (source_type, source_id)</a:t>
+            </a:r>
+          </a:p>
+          <a:p>
+            <a:pPr>
+              <a:defRPr sz="950">
+                <a:solidFill>
+                  <a:srgbClr val="94A3B8"/>
+                </a:solidFill>
+              </a:defRPr>
+            </a:pPr>
+            <a:r>
+              <a:t>30 Calls &amp; 14 Meetings occurring on local date 2026-08-21. Keyed strictly by composite tuple identity.</a:t>
+            </a:r>
+          </a:p>
+        </p:txBody>
+      </p:sp>
+      <p:sp>
+        <p:nvSpPr>
+          <p:cNvPr id="7" name="Rounded Rectangle 6"/>
+          <p:cNvSpPr/>
+          <p:nvPr/>
+        </p:nvSpPr>
+        <p:spPr>
+          <a:xfrm>
+            <a:off x="3456432" y="1371600"/>
+            <a:ext cx="2542032" cy="2103120"/>
+          </a:xfrm>
+          <a:prstGeom prst="roundRect">
+            <a:avLst/>
+          </a:prstGeom>
+          <a:solidFill>
+            <a:srgbClr val="131A2B"/>
+          </a:solidFill>
+          <a:ln w="15240">
+            <a:solidFill>
+              <a:srgbClr val="10B981"/>
+            </a:solidFill>
+          </a:ln>
+        </p:spPr>
+        <p:style>
+          <a:lnRef idx="1">
+            <a:schemeClr val="accent1"/>
+          </a:lnRef>
+          <a:fillRef idx="3">
+            <a:schemeClr val="accent1"/>
+          </a:fillRef>
+          <a:effectRef idx="2">
+            <a:schemeClr val="accent1"/>
+          </a:effectRef>
+          <a:fontRef idx="minor">
+            <a:schemeClr val="lt1"/>
+          </a:fontRef>
+        </p:style>
+        <p:txBody>
+          <a:bodyPr rtlCol="0" anchor="ctr"/>
+          <a:lstStyle/>
+          <a:p>
+            <a:pPr algn="ctr"/>
+          </a:p>
+        </p:txBody>
+      </p:sp>
+      <p:sp>
+        <p:nvSpPr>
+          <p:cNvPr id="8" name="TextBox 7"/>
+          <p:cNvSpPr txBox="1"/>
+          <p:nvPr/>
+        </p:nvSpPr>
+        <p:spPr>
+          <a:xfrm>
+            <a:off x="3566160" y="1508760"/>
+            <a:ext cx="2322576" cy="1828800"/>
+          </a:xfrm>
+          <a:prstGeom prst="rect">
+            <a:avLst/>
+          </a:prstGeom>
+          <a:noFill/>
+        </p:spPr>
+        <p:txBody>
+          <a:bodyPr wrap="square">
+            <a:spAutoFit/>
+          </a:bodyPr>
+          <a:lstStyle/>
+          <a:p>
+            <a:pPr>
+              <a:defRPr sz="1600" b="1">
+                <a:solidFill>
+                  <a:srgbClr val="10B981"/>
+                </a:solidFill>
+              </a:defRPr>
+            </a:pPr>
+            <a:r>
+              <a:t>17 ➔ 18 Transcripts</a:t>
             </a:r>
           </a:p>
           <a:p>
             <a:pPr>
               <a:spcAft>
-                <a:spcPts val="800"/>
+                <a:spcPts val="400"/>
               </a:spcAft>
-              <a:defRPr sz="1200" b="1">
+              <a:defRPr sz="1050" b="1">
                 <a:solidFill>
                   <a:srgbClr val="F8FAFC"/>
                 </a:solidFill>
               </a:defRPr>
             </a:pPr>
             <a:r>
-              <a:t>• Unique Source Records: 44 records (Rev 1) -&gt; 44 records (Rev 2) (Keyed strictly by (source_type, source_id). Higher revision updates in place.)</a:t>
+              <a:t>Coverage Jump: 38.6% ➔ 40.9%</a:t>
+            </a:r>
+          </a:p>
+          <a:p>
+            <a:pPr>
+              <a:defRPr sz="950">
+                <a:solidFill>
+                  <a:srgbClr val="94A3B8"/>
+                </a:solidFill>
+              </a:defRPr>
+            </a:pPr>
+            <a:r>
+              <a:t>Initial batch contains 17 usable transcripts. M07 update arrives in Rev 2, lifting coverage to 18 of 44 without duplicating records.</a:t>
+            </a:r>
+          </a:p>
+        </p:txBody>
+      </p:sp>
+      <p:sp>
+        <p:nvSpPr>
+          <p:cNvPr id="9" name="Rounded Rectangle 8"/>
+          <p:cNvSpPr/>
+          <p:nvPr/>
+        </p:nvSpPr>
+        <p:spPr>
+          <a:xfrm>
+            <a:off x="6181344" y="1371600"/>
+            <a:ext cx="2542032" cy="2103120"/>
+          </a:xfrm>
+          <a:prstGeom prst="roundRect">
+            <a:avLst/>
+          </a:prstGeom>
+          <a:solidFill>
+            <a:srgbClr val="131A2B"/>
+          </a:solidFill>
+          <a:ln w="15240">
+            <a:solidFill>
+              <a:srgbClr val="F59E0B"/>
+            </a:solidFill>
+          </a:ln>
+        </p:spPr>
+        <p:style>
+          <a:lnRef idx="1">
+            <a:schemeClr val="accent1"/>
+          </a:lnRef>
+          <a:fillRef idx="3">
+            <a:schemeClr val="accent1"/>
+          </a:fillRef>
+          <a:effectRef idx="2">
+            <a:schemeClr val="accent1"/>
+          </a:effectRef>
+          <a:fontRef idx="minor">
+            <a:schemeClr val="lt1"/>
+          </a:fontRef>
+        </p:style>
+        <p:txBody>
+          <a:bodyPr rtlCol="0" anchor="ctr"/>
+          <a:lstStyle/>
+          <a:p>
+            <a:pPr algn="ctr"/>
+          </a:p>
+        </p:txBody>
+      </p:sp>
+      <p:sp>
+        <p:nvSpPr>
+          <p:cNvPr id="10" name="TextBox 9"/>
+          <p:cNvSpPr txBox="1"/>
+          <p:nvPr/>
+        </p:nvSpPr>
+        <p:spPr>
+          <a:xfrm>
+            <a:off x="6291072" y="1508760"/>
+            <a:ext cx="2322576" cy="1828800"/>
+          </a:xfrm>
+          <a:prstGeom prst="rect">
+            <a:avLst/>
+          </a:prstGeom>
+          <a:noFill/>
+        </p:spPr>
+        <p:txBody>
+          <a:bodyPr wrap="square">
+            <a:spAutoFit/>
+          </a:bodyPr>
+          <a:lstStyle/>
+          <a:p>
+            <a:pPr>
+              <a:defRPr sz="1600" b="1">
+                <a:solidFill>
+                  <a:srgbClr val="F59E0B"/>
+                </a:solidFill>
+              </a:defRPr>
+            </a:pPr>
+            <a:r>
+              <a:t>9 / 30 Calls Connected</a:t>
             </a:r>
           </a:p>
           <a:p>
             <a:pPr>
               <a:spcAft>
-                <a:spcPts val="800"/>
+                <a:spcPts val="400"/>
               </a:spcAft>
-              <a:defRPr sz="1200" b="1">
+              <a:defRPr sz="1050" b="1">
                 <a:solidFill>
                   <a:srgbClr val="F8FAFC"/>
                 </a:solidFill>
               </a:defRPr>
             </a:pPr>
             <a:r>
-              <a:t>• Transcript Coverage: 17 / 44 (38.6%) -&gt; 18 / 44 (40.9%) (M07 arrives in Rev 2 with 27 turns, raising coverage from 17 to 18.)</a:t>
+              <a:t>Reported Connection Rate: 30%</a:t>
+            </a:r>
+          </a:p>
+          <a:p>
+            <a:pPr>
+              <a:defRPr sz="950">
+                <a:solidFill>
+                  <a:srgbClr val="94A3B8"/>
+                </a:solidFill>
+              </a:defRPr>
+            </a:pPr>
+            <a:r>
+              <a:t>Telephony reported 9 connected calls. However, audit reveals only 8 had substantive customer dialogue (C02/C04 hit voicemail).</a:t>
+            </a:r>
+          </a:p>
+        </p:txBody>
+      </p:sp>
+      <p:sp>
+        <p:nvSpPr>
+          <p:cNvPr id="11" name="Rounded Rectangle 10"/>
+          <p:cNvSpPr/>
+          <p:nvPr/>
+        </p:nvSpPr>
+        <p:spPr>
+          <a:xfrm>
+            <a:off x="8906256" y="1371600"/>
+            <a:ext cx="2542032" cy="2103120"/>
+          </a:xfrm>
+          <a:prstGeom prst="roundRect">
+            <a:avLst/>
+          </a:prstGeom>
+          <a:solidFill>
+            <a:srgbClr val="131A2B"/>
+          </a:solidFill>
+          <a:ln w="15240">
+            <a:solidFill>
+              <a:srgbClr val="6366F1"/>
+            </a:solidFill>
+          </a:ln>
+        </p:spPr>
+        <p:style>
+          <a:lnRef idx="1">
+            <a:schemeClr val="accent1"/>
+          </a:lnRef>
+          <a:fillRef idx="3">
+            <a:schemeClr val="accent1"/>
+          </a:fillRef>
+          <a:effectRef idx="2">
+            <a:schemeClr val="accent1"/>
+          </a:effectRef>
+          <a:fontRef idx="minor">
+            <a:schemeClr val="lt1"/>
+          </a:fontRef>
+        </p:style>
+        <p:txBody>
+          <a:bodyPr rtlCol="0" anchor="ctr"/>
+          <a:lstStyle/>
+          <a:p>
+            <a:pPr algn="ctr"/>
+          </a:p>
+        </p:txBody>
+      </p:sp>
+      <p:sp>
+        <p:nvSpPr>
+          <p:cNvPr id="12" name="TextBox 11"/>
+          <p:cNvSpPr txBox="1"/>
+          <p:nvPr/>
+        </p:nvSpPr>
+        <p:spPr>
+          <a:xfrm>
+            <a:off x="9015984" y="1508760"/>
+            <a:ext cx="2322576" cy="1828800"/>
+          </a:xfrm>
+          <a:prstGeom prst="rect">
+            <a:avLst/>
+          </a:prstGeom>
+          <a:noFill/>
+        </p:spPr>
+        <p:txBody>
+          <a:bodyPr wrap="square">
+            <a:spAutoFit/>
+          </a:bodyPr>
+          <a:lstStyle/>
+          <a:p>
+            <a:pPr>
+              <a:defRPr sz="1600" b="1">
+                <a:solidFill>
+                  <a:srgbClr val="6366F1"/>
+                </a:solidFill>
+              </a:defRPr>
+            </a:pPr>
+            <a:r>
+              <a:t>0 Duplicates / 44 Rejected</a:t>
             </a:r>
           </a:p>
           <a:p>
             <a:pPr>
               <a:spcAft>
-                <a:spcPts val="800"/>
+                <a:spcPts val="400"/>
               </a:spcAft>
-              <a:defRPr sz="1200" b="1">
+              <a:defRPr sz="1050" b="1">
                 <a:solidFill>
                   <a:srgbClr val="F8FAFC"/>
                 </a:solidFill>
               </a:defRPr>
             </a:pPr>
             <a:r>
-              <a:t>• Calls vs. Meetings Split: 30 Calls &amp; 14 Meetings (Partitioned strictly by source_type; remains constant across batches.)</a:t>
-            </a:r>
-          </a:p>
-          <a:p>
-            <a:pPr>
-              <a:spcAft>
-                <a:spcPts val="800"/>
-              </a:spcAft>
-              <a:defRPr sz="1200" b="1">
-                <a:solidFill>
-                  <a:srgbClr val="F8FAFC"/>
-                </a:solidFill>
-              </a:defRPr>
-            </a:pPr>
-            <a:r>
-              <a:t>• Source Connection Rate: 9 / 30 calls (30.0%) (Calls with is_connected=true / 30 calls. Exactly 8 had multi-turn prospect dialogue.)</a:t>
-            </a:r>
-          </a:p>
-          <a:p>
-            <a:pPr>
-              <a:spcBef>
-                <a:spcPts val="1200"/>
-              </a:spcBef>
+              <a:t>Strict Replay Idempotence</a:t>
+            </a:r>
+          </a:p>
+          <a:p>
+            <a:pPr>
+              <a:defRPr sz="950">
+                <a:solidFill>
+                  <a:srgbClr val="94A3B8"/>
+                </a:solidFill>
+              </a:defRPr>
+            </a:pPr>
+            <a:r>
+              <a:t>Re-ingesting initial batch in shuffled order safely ignores older/equal revisions. Zero duplicate records and zero count inflation.</a:t>
+            </a:r>
+          </a:p>
+        </p:txBody>
+      </p:sp>
+      <p:sp>
+        <p:nvSpPr>
+          <p:cNvPr id="13" name="Rounded Rectangle 12"/>
+          <p:cNvSpPr/>
+          <p:nvPr/>
+        </p:nvSpPr>
+        <p:spPr>
+          <a:xfrm>
+            <a:off x="731520" y="3703320"/>
+            <a:ext cx="10728655" cy="2423160"/>
+          </a:xfrm>
+          <a:prstGeom prst="roundRect">
+            <a:avLst/>
+          </a:prstGeom>
+          <a:solidFill>
+            <a:srgbClr val="131A2B"/>
+          </a:solidFill>
+          <a:ln w="15240">
+            <a:solidFill>
+              <a:srgbClr val="25304D"/>
+            </a:solidFill>
+          </a:ln>
+        </p:spPr>
+        <p:style>
+          <a:lnRef idx="1">
+            <a:schemeClr val="accent1"/>
+          </a:lnRef>
+          <a:fillRef idx="3">
+            <a:schemeClr val="accent1"/>
+          </a:fillRef>
+          <a:effectRef idx="2">
+            <a:schemeClr val="accent1"/>
+          </a:effectRef>
+          <a:fontRef idx="minor">
+            <a:schemeClr val="lt1"/>
+          </a:fontRef>
+        </p:style>
+        <p:txBody>
+          <a:bodyPr rtlCol="0" anchor="ctr"/>
+          <a:lstStyle/>
+          <a:p>
+            <a:pPr algn="ctr"/>
+          </a:p>
+        </p:txBody>
+      </p:sp>
+      <p:sp>
+        <p:nvSpPr>
+          <p:cNvPr id="14" name="TextBox 13"/>
+          <p:cNvSpPr txBox="1"/>
+          <p:nvPr/>
+        </p:nvSpPr>
+        <p:spPr>
+          <a:xfrm>
+            <a:off x="914400" y="3794760"/>
+            <a:ext cx="10362895" cy="2240280"/>
+          </a:xfrm>
+          <a:prstGeom prst="rect">
+            <a:avLst/>
+          </a:prstGeom>
+          <a:noFill/>
+        </p:spPr>
+        <p:txBody>
+          <a:bodyPr wrap="square">
+            <a:spAutoFit/>
+          </a:bodyPr>
+          <a:lstStyle/>
+          <a:p>
+            <a:pPr>
               <a:spcAft>
                 <a:spcPts val="600"/>
               </a:spcAft>
-              <a:defRPr sz="1400" b="1">
-                <a:solidFill>
-                  <a:srgbClr val="10B981"/>
-                </a:solidFill>
-              </a:defRPr>
-            </a:pPr>
-            <a:r>
-              <a:t>Repeat Import Idempotence Test:</a:t>
-            </a:r>
-          </a:p>
-          <a:p>
-            <a:pPr>
-              <a:defRPr sz="1200">
-                <a:solidFill>
-                  <a:srgbClr val="94A3B8"/>
-                </a:solidFill>
-              </a:defRPr>
-            </a:pPr>
-            <a:r>
-              <a:t>Re-importing Batch 1 with altered record order confirms strict idempotence: 0 duplicates added, 44 duplicates safely rejected, zero metric inflation.</a:t>
+              <a:defRPr sz="1200" b="1">
+                <a:solidFill>
+                  <a:srgbClr val="6366F1"/>
+                </a:solidFill>
+              </a:defRPr>
+            </a:pPr>
+            <a:r>
+              <a:t>DATA_CONTRACT.md 5-STEP REPLAY AUDIT TRAIL</a:t>
+            </a:r>
+          </a:p>
+          <a:p>
+            <a:pPr>
+              <a:spcAft>
+                <a:spcPts val="300"/>
+              </a:spcAft>
+              <a:defRPr sz="1050" b="1">
+                <a:solidFill>
+                  <a:srgbClr val="F8FAFC"/>
+                </a:solidFill>
+              </a:defRPr>
+            </a:pPr>
+            <a:r>
+              <a:t>• Step 1 (Initial Import): Ingests 01_initial.json. Establishes baseline: 44 unique records, 17 usable transcripts (38.6% coverage).</a:t>
+            </a:r>
+          </a:p>
+          <a:p>
+            <a:pPr>
+              <a:spcAft>
+                <a:spcPts val="300"/>
+              </a:spcAft>
+              <a:defRPr sz="1050" b="1">
+                <a:solidFill>
+                  <a:srgbClr val="F8FAFC"/>
+                </a:solidFill>
+              </a:defRPr>
+            </a:pPr>
+            <a:r>
+              <a:t>• Step 2 (Repeat Idempotence): Re-imports 01_initial.json in shuffled order. Strict idempotency confirmed: 0 new records, 44 duplicates safely rejected.</a:t>
+            </a:r>
+          </a:p>
+          <a:p>
+            <a:pPr>
+              <a:spcAft>
+                <a:spcPts val="300"/>
+              </a:spcAft>
+              <a:defRPr sz="1050" b="1">
+                <a:solidFill>
+                  <a:srgbClr val="F8FAFC"/>
+                </a:solidFill>
+              </a:defRPr>
+            </a:pPr>
+            <a:r>
+              <a:t>• Step 3 (Manual Route Correction): Simulates manager judgment: route for M07 changed to 'Customer Success / Bug Escalation' with yellow badge.</a:t>
+            </a:r>
+          </a:p>
+          <a:p>
+            <a:pPr>
+              <a:spcAft>
+                <a:spcPts val="300"/>
+              </a:spcAft>
+              <a:defRPr sz="1050" b="1">
+                <a:solidFill>
+                  <a:srgbClr val="F8FAFC"/>
+                </a:solidFill>
+              </a:defRPr>
+            </a:pPr>
+            <a:r>
+              <a:t>• Step 4 (Ingest Late Update): Ingests 02_update.json. M07 updated to Rev 2 with 27 turns. Coverage jumps 17 ➔ 18. Total records remains exactly 44.</a:t>
+            </a:r>
+          </a:p>
+          <a:p>
+            <a:pPr>
+              <a:spcAft>
+                <a:spcPts val="300"/>
+              </a:spcAft>
+              <a:defRPr sz="1050" b="1">
+                <a:solidFill>
+                  <a:srgbClr val="F8FAFC"/>
+                </a:solidFill>
+              </a:defRPr>
+            </a:pPr>
+            <a:r>
+              <a:t>• Step 5 (Preserve Judgment): Re-imports Rev 1. Because M07 is already at Rev 2, Rev 1 is safely ignored. Manager's manual override survives intact.</a:t>
             </a:r>
           </a:p>
         </p:txBody>
@@ -4218,8 +5574,8 @@
         </p:nvSpPr>
         <p:spPr>
           <a:xfrm>
-            <a:off x="731520" y="457200"/>
-            <a:ext cx="10698480" cy="365760"/>
+            <a:off x="731520" y="365760"/>
+            <a:ext cx="10698480" cy="320040"/>
           </a:xfrm>
           <a:prstGeom prst="rect">
             <a:avLst/>
@@ -4227,20 +5583,20 @@
           <a:noFill/>
         </p:spPr>
         <p:txBody>
-          <a:bodyPr wrap="none">
+          <a:bodyPr wrap="square">
             <a:spAutoFit/>
           </a:bodyPr>
           <a:lstStyle/>
           <a:p>
             <a:pPr>
-              <a:defRPr sz="1100" b="1">
+              <a:defRPr sz="1000" b="1">
                 <a:solidFill>
                   <a:srgbClr val="06B6D4"/>
                 </a:solidFill>
               </a:defRPr>
             </a:pPr>
             <a:r>
-              <a:t>SLIDE 5 • ENGINEERING ETHICS &amp; AI DISCLOSURE</a:t>
+              <a:t>VOLOPAY EVALUATION  •  SLIDE 5 • ETHICS, AI USAGE &amp; PRODUCT EVOLUTION</a:t>
             </a:r>
           </a:p>
         </p:txBody>
@@ -4253,8 +5609,8 @@
         </p:nvSpPr>
         <p:spPr>
           <a:xfrm>
-            <a:off x="731520" y="777240"/>
-            <a:ext cx="10698480" cy="640080"/>
+            <a:off x="731520" y="685800"/>
+            <a:ext cx="10698480" cy="594360"/>
           </a:xfrm>
           <a:prstGeom prst="rect">
             <a:avLst/>
@@ -4262,20 +5618,20 @@
           <a:noFill/>
         </p:spPr>
         <p:txBody>
-          <a:bodyPr wrap="none">
+          <a:bodyPr wrap="square">
             <a:spAutoFit/>
           </a:bodyPr>
           <a:lstStyle/>
           <a:p>
             <a:pPr>
-              <a:defRPr sz="2400" b="1">
+              <a:defRPr sz="2200" b="1">
                 <a:solidFill>
                   <a:srgbClr val="F8FAFC"/>
                 </a:solidFill>
               </a:defRPr>
             </a:pPr>
             <a:r>
-              <a:t>5. Trade-offs, Rejected Decision &amp; Next Steps</a:t>
+              <a:t>5. Trade-offs, Rejected Decision &amp; System Limitations</a:t>
             </a:r>
           </a:p>
         </p:txBody>
@@ -4288,7 +5644,7 @@
         </p:nvSpPr>
         <p:spPr>
           <a:xfrm>
-            <a:off x="731520" y="6217920"/>
+            <a:off x="731520" y="6309360"/>
             <a:ext cx="10698480" cy="365760"/>
           </a:xfrm>
           <a:prstGeom prst="rect">
@@ -4303,28 +5659,73 @@
           <a:lstStyle/>
           <a:p>
             <a:pPr>
-              <a:defRPr sz="1000">
+              <a:defRPr sz="950">
                 <a:solidFill>
                   <a:srgbClr val="94A3B8"/>
                 </a:solidFill>
               </a:defRPr>
             </a:pPr>
             <a:r>
-              <a:t>SpendNest Revenue Intelligence Inbox — Volopay Assessment | Slide 5 of 5</a:t>
-            </a:r>
-          </a:p>
-        </p:txBody>
-      </p:sp>
-      <p:sp>
-        <p:nvSpPr>
-          <p:cNvPr id="5" name="TextBox 4"/>
+              <a:t>SpendNest Revenue Intelligence Inbox  •  Candidate: Dinesh Madhavan M  •  Live: https://volopay-assignment-inqe.onrender.com  •  Slide 5 of 5</a:t>
+            </a:r>
+          </a:p>
+        </p:txBody>
+      </p:sp>
+      <p:sp>
+        <p:nvSpPr>
+          <p:cNvPr id="5" name="Rounded Rectangle 4"/>
+          <p:cNvSpPr/>
+          <p:nvPr/>
+        </p:nvSpPr>
+        <p:spPr>
+          <a:xfrm>
+            <a:off x="731520" y="1371600"/>
+            <a:ext cx="5248656" cy="4754880"/>
+          </a:xfrm>
+          <a:prstGeom prst="roundRect">
+            <a:avLst/>
+          </a:prstGeom>
+          <a:solidFill>
+            <a:srgbClr val="131A2B"/>
+          </a:solidFill>
+          <a:ln w="15240">
+            <a:solidFill>
+              <a:srgbClr val="EF4444"/>
+            </a:solidFill>
+          </a:ln>
+        </p:spPr>
+        <p:style>
+          <a:lnRef idx="1">
+            <a:schemeClr val="accent1"/>
+          </a:lnRef>
+          <a:fillRef idx="3">
+            <a:schemeClr val="accent1"/>
+          </a:fillRef>
+          <a:effectRef idx="2">
+            <a:schemeClr val="accent1"/>
+          </a:effectRef>
+          <a:fontRef idx="minor">
+            <a:schemeClr val="lt1"/>
+          </a:fontRef>
+        </p:style>
+        <p:txBody>
+          <a:bodyPr rtlCol="0" anchor="ctr"/>
+          <a:lstStyle/>
+          <a:p>
+            <a:pPr algn="ctr"/>
+          </a:p>
+        </p:txBody>
+      </p:sp>
+      <p:sp>
+        <p:nvSpPr>
+          <p:cNvPr id="6" name="TextBox 5"/>
           <p:cNvSpPr txBox="1"/>
           <p:nvPr/>
         </p:nvSpPr>
         <p:spPr>
           <a:xfrm>
-            <a:off x="731520" y="1463040"/>
-            <a:ext cx="10698480" cy="4572000"/>
+            <a:off x="914400" y="1554480"/>
+            <a:ext cx="4882896" cy="4389120"/>
           </a:xfrm>
           <a:prstGeom prst="rect">
             <a:avLst/>
@@ -4339,39 +5740,28 @@
           <a:p>
             <a:pPr>
               <a:spcAft>
-                <a:spcPts val="800"/>
+                <a:spcPts val="1000"/>
               </a:spcAft>
-              <a:defRPr sz="1400" b="1">
+              <a:defRPr sz="1200" b="1">
                 <a:solidFill>
                   <a:srgbClr val="EF4444"/>
                 </a:solidFill>
               </a:defRPr>
             </a:pPr>
             <a:r>
-              <a:t>The Deliberately Rejected Decision: Auto-Estimating Deal Pipeline ARR</a:t>
-            </a:r>
-          </a:p>
-          <a:p>
-            <a:pPr>
-              <a:spcAft>
-                <a:spcPts val="1400"/>
-              </a:spcAft>
-              <a:defRPr sz="1100">
-                <a:solidFill>
-                  <a:srgbClr val="94A3B8"/>
-                </a:solidFill>
-              </a:defRPr>
-            </a:pPr>
-            <a:r>
-              <a:t>• Alternative Considered: Using an LLM to hallucinate contract values based on prospect employee counts (e.g. estimating Asterloom at $45,000 ARR).</a:t>
-            </a:r>
-            <a:br/>
-            <a:r>
-              <a:t>• Why Rejected: The prompt strictly prohibits inventing pipeline value or deal outcomes. Speculative revenue figures destroy executive trust during audits.</a:t>
-            </a:r>
-            <a:br/>
-            <a:r>
-              <a:t>• Accepted Trade-off: We report qualitative commercial intent and verbatim financial statements (e.g. Asterloom's INR 26-39 lakh monthly vendor spend) without guessing ARR.</a:t>
+              <a:t>THE DELIBERATELY REJECTED DECISION</a:t>
+            </a:r>
+          </a:p>
+          <a:p>
+            <a:pPr>
+              <a:defRPr sz="1100" b="1">
+                <a:solidFill>
+                  <a:srgbClr val="F8FAFC"/>
+                </a:solidFill>
+              </a:defRPr>
+            </a:pPr>
+            <a:r>
+              <a:t>Alternative Considered:</a:t>
             </a:r>
           </a:p>
           <a:p>
@@ -4379,34 +5769,272 @@
               <a:spcAft>
                 <a:spcPts val="800"/>
               </a:spcAft>
-              <a:defRPr sz="1400" b="1">
+              <a:defRPr sz="1050">
+                <a:solidFill>
+                  <a:srgbClr val="94A3B8"/>
+                </a:solidFill>
+              </a:defRPr>
+            </a:pPr>
+            <a:r>
+              <a:t>Using an LLM to guess deal ARR values from company names and employee estimates (e.g. projecting Asterloom as a $45,000 ARR deal).</a:t>
+            </a:r>
+          </a:p>
+          <a:p>
+            <a:pPr>
+              <a:defRPr sz="1100" b="1">
+                <a:solidFill>
+                  <a:srgbClr val="EF4444"/>
+                </a:solidFill>
+              </a:defRPr>
+            </a:pPr>
+            <a:r>
+              <a:t>Why It Was Rejected:</a:t>
+            </a:r>
+          </a:p>
+          <a:p>
+            <a:pPr>
+              <a:spcAft>
+                <a:spcPts val="800"/>
+              </a:spcAft>
+              <a:defRPr sz="1050">
+                <a:solidFill>
+                  <a:srgbClr val="94A3B8"/>
+                </a:solidFill>
+              </a:defRPr>
+            </a:pPr>
+            <a:r>
+              <a:t>The brief explicitly mandates: 'Do not invent pipeline value, deal outcomes or account links that the data does not establish.' Hallucinating speculative financial numbers damages executive trust and misleads sales leadership.</a:t>
+            </a:r>
+          </a:p>
+          <a:p>
+            <a:pPr>
+              <a:defRPr sz="1100" b="1">
+                <a:solidFill>
+                  <a:srgbClr val="10B981"/>
+                </a:solidFill>
+              </a:defRPr>
+            </a:pPr>
+            <a:r>
+              <a:t>Accepted Trade-off &amp; Product Result:</a:t>
+            </a:r>
+          </a:p>
+          <a:p>
+            <a:pPr>
+              <a:defRPr sz="1050">
+                <a:solidFill>
+                  <a:srgbClr val="94A3B8"/>
+                </a:solidFill>
+              </a:defRPr>
+            </a:pPr>
+            <a:r>
+              <a:t>We display qualitative commercial intent alongside verbatim financial statements (e.g., Asterloom's INR 26-39 lakh monthly vendor spend) without guessing synthetic revenue.</a:t>
+            </a:r>
+          </a:p>
+        </p:txBody>
+      </p:sp>
+      <p:sp>
+        <p:nvSpPr>
+          <p:cNvPr id="7" name="Rounded Rectangle 6"/>
+          <p:cNvSpPr/>
+          <p:nvPr/>
+        </p:nvSpPr>
+        <p:spPr>
+          <a:xfrm>
+            <a:off x="6199632" y="1371600"/>
+            <a:ext cx="5248656" cy="4754880"/>
+          </a:xfrm>
+          <a:prstGeom prst="roundRect">
+            <a:avLst/>
+          </a:prstGeom>
+          <a:solidFill>
+            <a:srgbClr val="131A2B"/>
+          </a:solidFill>
+          <a:ln w="15240">
+            <a:solidFill>
+              <a:srgbClr val="6366F1"/>
+            </a:solidFill>
+          </a:ln>
+        </p:spPr>
+        <p:style>
+          <a:lnRef idx="1">
+            <a:schemeClr val="accent1"/>
+          </a:lnRef>
+          <a:fillRef idx="3">
+            <a:schemeClr val="accent1"/>
+          </a:fillRef>
+          <a:effectRef idx="2">
+            <a:schemeClr val="accent1"/>
+          </a:effectRef>
+          <a:fontRef idx="minor">
+            <a:schemeClr val="lt1"/>
+          </a:fontRef>
+        </p:style>
+        <p:txBody>
+          <a:bodyPr rtlCol="0" anchor="ctr"/>
+          <a:lstStyle/>
+          <a:p>
+            <a:pPr algn="ctr"/>
+          </a:p>
+        </p:txBody>
+      </p:sp>
+      <p:sp>
+        <p:nvSpPr>
+          <p:cNvPr id="8" name="TextBox 7"/>
+          <p:cNvSpPr txBox="1"/>
+          <p:nvPr/>
+        </p:nvSpPr>
+        <p:spPr>
+          <a:xfrm>
+            <a:off x="6400800" y="1554480"/>
+            <a:ext cx="4882896" cy="4389120"/>
+          </a:xfrm>
+          <a:prstGeom prst="rect">
+            <a:avLst/>
+          </a:prstGeom>
+          <a:noFill/>
+        </p:spPr>
+        <p:txBody>
+          <a:bodyPr wrap="square">
+            <a:spAutoFit/>
+          </a:bodyPr>
+          <a:lstStyle/>
+          <a:p>
+            <a:pPr>
+              <a:spcAft>
+                <a:spcPts val="1000"/>
+              </a:spcAft>
+              <a:defRPr sz="1200" b="1">
                 <a:solidFill>
                   <a:srgbClr val="6366F1"/>
                 </a:solidFill>
               </a:defRPr>
             </a:pPr>
             <a:r>
-              <a:t>AI Implementation &amp; Architecture Disclosure:</a:t>
-            </a:r>
-          </a:p>
-          <a:p>
-            <a:pPr>
-              <a:defRPr sz="1100">
+              <a:t>AI DISCLOSURE, TIME SPENT &amp; ROADMAP</a:t>
+            </a:r>
+          </a:p>
+          <a:p>
+            <a:pPr>
+              <a:defRPr sz="1100" b="1">
+                <a:solidFill>
+                  <a:srgbClr val="F8FAFC"/>
+                </a:solidFill>
+              </a:defRPr>
+            </a:pPr>
+            <a:r>
+              <a:t>• Pre-Generated vs. Dynamic Runtime Operations</a:t>
+            </a:r>
+          </a:p>
+          <a:p>
+            <a:pPr>
+              <a:spcAft>
+                <a:spcPts val="600"/>
+              </a:spcAft>
+              <a:defRPr sz="980">
                 <a:solidFill>
                   <a:srgbClr val="94A3B8"/>
                 </a:solidFill>
               </a:defRPr>
             </a:pPr>
             <a:r>
-              <a:t>• Pre-generated vs. Dynamic: Conversation analyses and evidence citations were prepared beforehand. Batch ingestion, revision deduplication, manual override persistence, and ZIP manifest generation run completely dynamically client-side in the browser.</a:t>
+              <a:t>Conversation analyses, route rationales, and evidence quotes were prepared beforehand to guarantee factual citations and eliminate runtime hallucination. Ingestion deduplication, revision handling, override persistence, and ZIP packaging run dynamically in the client browser.</a:t>
+            </a:r>
+          </a:p>
+          <a:p>
+            <a:pPr>
+              <a:defRPr sz="1100" b="1">
+                <a:solidFill>
+                  <a:srgbClr val="F8FAFC"/>
+                </a:solidFill>
+              </a:defRPr>
+            </a:pPr>
+            <a:r>
+              <a:t>• Approximate Hours Spent (~7 Hours Total)</a:t>
+            </a:r>
+          </a:p>
+          <a:p>
+            <a:pPr>
+              <a:spcAft>
+                <a:spcPts val="600"/>
+              </a:spcAft>
+              <a:defRPr sz="980">
+                <a:solidFill>
+                  <a:srgbClr val="94A3B8"/>
+                </a:solidFill>
+              </a:defRPr>
+            </a:pPr>
+            <a:r>
+              <a:t>• Data Contract &amp; Record Modeling: 2.5 hours</a:t>
             </a:r>
             <a:br/>
             <a:r>
-              <a:t>• Approximate Time Spent: ~7 hours total (modeling, UI design, contract compliance, documentation).</a:t>
+              <a:t>• Web Dashboard &amp; Design System: 2.5 hours</a:t>
             </a:r>
             <a:br/>
             <a:r>
-              <a:t>• Known Limitations &amp; Future Scope: Cross-call speaker identity is not unified upstream. Future release will integrate live webhooks for automated recording synchronization.</a:t>
+              <a:t>• Manifest &amp; ZIP Export Engine: 1.0 hour</a:t>
+            </a:r>
+            <a:br/>
+            <a:r>
+              <a:t>• Verification, Documentation &amp; Slides: 1.0 hour</a:t>
+            </a:r>
+          </a:p>
+          <a:p>
+            <a:pPr>
+              <a:defRPr sz="1100" b="1">
+                <a:solidFill>
+                  <a:srgbClr val="F8FAFC"/>
+                </a:solidFill>
+              </a:defRPr>
+            </a:pPr>
+            <a:r>
+              <a:t>• Known System Limitations</a:t>
+            </a:r>
+          </a:p>
+          <a:p>
+            <a:pPr>
+              <a:spcAft>
+                <a:spcPts val="600"/>
+              </a:spcAft>
+              <a:defRPr sz="980">
+                <a:solidFill>
+                  <a:srgbClr val="94A3B8"/>
+                </a:solidFill>
+              </a:defRPr>
+            </a:pPr>
+            <a:r>
+              <a:t>Cross-call speaker identity is not unified upstream. An organizer email is not automatically confirmed as an attendee or quota-carrying salesperson.</a:t>
+            </a:r>
+          </a:p>
+          <a:p>
+            <a:pPr>
+              <a:defRPr sz="1100" b="1">
+                <a:solidFill>
+                  <a:srgbClr val="F8FAFC"/>
+                </a:solidFill>
+              </a:defRPr>
+            </a:pPr>
+            <a:r>
+              <a:t>• Future Improvements (Next Iteration)</a:t>
+            </a:r>
+          </a:p>
+          <a:p>
+            <a:pPr>
+              <a:spcAft>
+                <a:spcPts val="600"/>
+              </a:spcAft>
+              <a:defRPr sz="980">
+                <a:solidFill>
+                  <a:srgbClr val="94A3B8"/>
+                </a:solidFill>
+              </a:defRPr>
+            </a:pPr>
+            <a:r>
+              <a:t>1. Real-time telephony webhook ingestion for live Gong/Zoom calls.</a:t>
+            </a:r>
+            <a:br/>
+            <a:r>
+              <a:t>2. Bi-directional CRM sync for automated override persistence.</a:t>
             </a:r>
           </a:p>
         </p:txBody>

</xml_diff>